<commit_message>
Remove table background colors from slide 8
Co-Authored-By: Claude Sonnet 4.6 <noreply@anthropic.com>
Claude-Session: https://claude.ai/code/session_017fvmJuBTTSQYZTwFUTf1rX
</commit_message>
<xml_diff>
--- a/public/slides_8_to_11.pptx
+++ b/public/slides_8_to_11.pptx
@@ -3167,9 +3167,7 @@
                     </a:p>
                   </a:txBody>
                   <a:tcPr>
-                    <a:solidFill>
-                      <a:srgbClr val="DCDCDC"/>
-                    </a:solidFill>
+                    <a:noFill/>
                   </a:tcPr>
                 </a:tc>
                 <a:tc>
@@ -3187,9 +3185,7 @@
                     </a:p>
                   </a:txBody>
                   <a:tcPr>
-                    <a:solidFill>
-                      <a:srgbClr val="DCDCDC"/>
-                    </a:solidFill>
+                    <a:noFill/>
                   </a:tcPr>
                 </a:tc>
                 <a:tc>
@@ -3207,9 +3203,7 @@
                     </a:p>
                   </a:txBody>
                   <a:tcPr>
-                    <a:solidFill>
-                      <a:srgbClr val="DCDCDC"/>
-                    </a:solidFill>
+                    <a:noFill/>
                   </a:tcPr>
                 </a:tc>
                 <a:tc>
@@ -3227,9 +3221,7 @@
                     </a:p>
                   </a:txBody>
                   <a:tcPr>
-                    <a:solidFill>
-                      <a:srgbClr val="DCDCDC"/>
-                    </a:solidFill>
+                    <a:noFill/>
                   </a:tcPr>
                 </a:tc>
                 <a:tc>
@@ -3247,9 +3239,7 @@
                     </a:p>
                   </a:txBody>
                   <a:tcPr>
-                    <a:solidFill>
-                      <a:srgbClr val="DCDCDC"/>
-                    </a:solidFill>
+                    <a:noFill/>
                   </a:tcPr>
                 </a:tc>
               </a:tr>
@@ -3268,7 +3258,9 @@
                       </a:r>
                     </a:p>
                   </a:txBody>
-                  <a:tcPr/>
+                  <a:tcPr>
+                    <a:noFill/>
+                  </a:tcPr>
                 </a:tc>
                 <a:tc>
                   <a:txBody>
@@ -3284,7 +3276,9 @@
                       </a:r>
                     </a:p>
                   </a:txBody>
-                  <a:tcPr/>
+                  <a:tcPr>
+                    <a:noFill/>
+                  </a:tcPr>
                 </a:tc>
                 <a:tc>
                   <a:txBody>
@@ -3300,7 +3294,9 @@
                       </a:r>
                     </a:p>
                   </a:txBody>
-                  <a:tcPr/>
+                  <a:tcPr>
+                    <a:noFill/>
+                  </a:tcPr>
                 </a:tc>
                 <a:tc>
                   <a:txBody>
@@ -3316,7 +3312,9 @@
                       </a:r>
                     </a:p>
                   </a:txBody>
-                  <a:tcPr/>
+                  <a:tcPr>
+                    <a:noFill/>
+                  </a:tcPr>
                 </a:tc>
                 <a:tc>
                   <a:txBody>
@@ -3332,7 +3330,9 @@
                       </a:r>
                     </a:p>
                   </a:txBody>
-                  <a:tcPr/>
+                  <a:tcPr>
+                    <a:noFill/>
+                  </a:tcPr>
                 </a:tc>
               </a:tr>
               <a:tr h="600891">
@@ -3350,7 +3350,9 @@
                       </a:r>
                     </a:p>
                   </a:txBody>
-                  <a:tcPr/>
+                  <a:tcPr>
+                    <a:noFill/>
+                  </a:tcPr>
                 </a:tc>
                 <a:tc>
                   <a:txBody>
@@ -3366,7 +3368,9 @@
                       </a:r>
                     </a:p>
                   </a:txBody>
-                  <a:tcPr/>
+                  <a:tcPr>
+                    <a:noFill/>
+                  </a:tcPr>
                 </a:tc>
                 <a:tc>
                   <a:txBody>
@@ -3382,7 +3386,9 @@
                       </a:r>
                     </a:p>
                   </a:txBody>
-                  <a:tcPr/>
+                  <a:tcPr>
+                    <a:noFill/>
+                  </a:tcPr>
                 </a:tc>
                 <a:tc>
                   <a:txBody>
@@ -3398,7 +3404,9 @@
                       </a:r>
                     </a:p>
                   </a:txBody>
-                  <a:tcPr/>
+                  <a:tcPr>
+                    <a:noFill/>
+                  </a:tcPr>
                 </a:tc>
                 <a:tc>
                   <a:txBody>
@@ -3414,7 +3422,9 @@
                       </a:r>
                     </a:p>
                   </a:txBody>
-                  <a:tcPr/>
+                  <a:tcPr>
+                    <a:noFill/>
+                  </a:tcPr>
                 </a:tc>
               </a:tr>
               <a:tr h="600891">
@@ -3432,7 +3442,9 @@
                       </a:r>
                     </a:p>
                   </a:txBody>
-                  <a:tcPr/>
+                  <a:tcPr>
+                    <a:noFill/>
+                  </a:tcPr>
                 </a:tc>
                 <a:tc>
                   <a:txBody>
@@ -3448,7 +3460,9 @@
                       </a:r>
                     </a:p>
                   </a:txBody>
-                  <a:tcPr/>
+                  <a:tcPr>
+                    <a:noFill/>
+                  </a:tcPr>
                 </a:tc>
                 <a:tc>
                   <a:txBody>
@@ -3464,7 +3478,9 @@
                       </a:r>
                     </a:p>
                   </a:txBody>
-                  <a:tcPr/>
+                  <a:tcPr>
+                    <a:noFill/>
+                  </a:tcPr>
                 </a:tc>
                 <a:tc>
                   <a:txBody>
@@ -3480,7 +3496,9 @@
                       </a:r>
                     </a:p>
                   </a:txBody>
-                  <a:tcPr/>
+                  <a:tcPr>
+                    <a:noFill/>
+                  </a:tcPr>
                 </a:tc>
                 <a:tc>
                   <a:txBody>
@@ -3496,7 +3514,9 @@
                       </a:r>
                     </a:p>
                   </a:txBody>
-                  <a:tcPr/>
+                  <a:tcPr>
+                    <a:noFill/>
+                  </a:tcPr>
                 </a:tc>
               </a:tr>
               <a:tr h="600891">
@@ -3514,7 +3534,9 @@
                       </a:r>
                     </a:p>
                   </a:txBody>
-                  <a:tcPr/>
+                  <a:tcPr>
+                    <a:noFill/>
+                  </a:tcPr>
                 </a:tc>
                 <a:tc>
                   <a:txBody>
@@ -3530,7 +3552,9 @@
                       </a:r>
                     </a:p>
                   </a:txBody>
-                  <a:tcPr/>
+                  <a:tcPr>
+                    <a:noFill/>
+                  </a:tcPr>
                 </a:tc>
                 <a:tc>
                   <a:txBody>
@@ -3546,7 +3570,9 @@
                       </a:r>
                     </a:p>
                   </a:txBody>
-                  <a:tcPr/>
+                  <a:tcPr>
+                    <a:noFill/>
+                  </a:tcPr>
                 </a:tc>
                 <a:tc>
                   <a:txBody>
@@ -3562,7 +3588,9 @@
                       </a:r>
                     </a:p>
                   </a:txBody>
-                  <a:tcPr/>
+                  <a:tcPr>
+                    <a:noFill/>
+                  </a:tcPr>
                 </a:tc>
                 <a:tc>
                   <a:txBody>
@@ -3578,7 +3606,9 @@
                       </a:r>
                     </a:p>
                   </a:txBody>
-                  <a:tcPr/>
+                  <a:tcPr>
+                    <a:noFill/>
+                  </a:tcPr>
                 </a:tc>
               </a:tr>
               <a:tr h="600891">
@@ -3597,9 +3627,7 @@
                     </a:p>
                   </a:txBody>
                   <a:tcPr>
-                    <a:solidFill>
-                      <a:srgbClr val="FFFBE6"/>
-                    </a:solidFill>
+                    <a:noFill/>
                   </a:tcPr>
                 </a:tc>
                 <a:tc>
@@ -3617,9 +3645,7 @@
                     </a:p>
                   </a:txBody>
                   <a:tcPr>
-                    <a:solidFill>
-                      <a:srgbClr val="FFFBE6"/>
-                    </a:solidFill>
+                    <a:noFill/>
                   </a:tcPr>
                 </a:tc>
                 <a:tc>
@@ -3629,10 +3655,7 @@
                     <a:p>
                       <a:pPr algn="ctr"/>
                       <a:r>
-                        <a:rPr sz="1400" b="1">
-                          <a:solidFill>
-                            <a:srgbClr val="B40000"/>
-                          </a:solidFill>
+                        <a:rPr sz="1400">
                           <a:latin typeface="Yu Gothic"/>
                         </a:rPr>
                         <a:t>no</a:t>
@@ -3640,9 +3663,7 @@
                     </a:p>
                   </a:txBody>
                   <a:tcPr>
-                    <a:solidFill>
-                      <a:srgbClr val="FFFBE6"/>
-                    </a:solidFill>
+                    <a:noFill/>
                   </a:tcPr>
                 </a:tc>
                 <a:tc>
@@ -3660,9 +3681,7 @@
                     </a:p>
                   </a:txBody>
                   <a:tcPr>
-                    <a:solidFill>
-                      <a:srgbClr val="FFFBE6"/>
-                    </a:solidFill>
+                    <a:noFill/>
                   </a:tcPr>
                 </a:tc>
                 <a:tc>
@@ -3672,10 +3691,7 @@
                     <a:p>
                       <a:pPr algn="ctr"/>
                       <a:r>
-                        <a:rPr sz="1400" b="1">
-                          <a:solidFill>
-                            <a:srgbClr val="B40000"/>
-                          </a:solidFill>
+                        <a:rPr sz="1400">
                           <a:latin typeface="Yu Gothic"/>
                         </a:rPr>
                         <a:t>no</a:t>
@@ -3683,9 +3699,7 @@
                     </a:p>
                   </a:txBody>
                   <a:tcPr>
-                    <a:solidFill>
-                      <a:srgbClr val="FFFBE6"/>
-                    </a:solidFill>
+                    <a:noFill/>
                   </a:tcPr>
                 </a:tc>
               </a:tr>
@@ -3705,9 +3719,7 @@
                     </a:p>
                   </a:txBody>
                   <a:tcPr>
-                    <a:solidFill>
-                      <a:srgbClr val="FFFBE6"/>
-                    </a:solidFill>
+                    <a:noFill/>
                   </a:tcPr>
                 </a:tc>
                 <a:tc>
@@ -3725,9 +3737,7 @@
                     </a:p>
                   </a:txBody>
                   <a:tcPr>
-                    <a:solidFill>
-                      <a:srgbClr val="FFFBE6"/>
-                    </a:solidFill>
+                    <a:noFill/>
                   </a:tcPr>
                 </a:tc>
                 <a:tc>
@@ -3745,9 +3755,7 @@
                     </a:p>
                   </a:txBody>
                   <a:tcPr>
-                    <a:solidFill>
-                      <a:srgbClr val="FFFBE6"/>
-                    </a:solidFill>
+                    <a:noFill/>
                   </a:tcPr>
                 </a:tc>
                 <a:tc>
@@ -3757,10 +3765,7 @@
                     <a:p>
                       <a:pPr algn="ctr"/>
                       <a:r>
-                        <a:rPr sz="1400" b="1">
-                          <a:solidFill>
-                            <a:srgbClr val="B40000"/>
-                          </a:solidFill>
+                        <a:rPr sz="1400">
                           <a:latin typeface="Yu Gothic"/>
                         </a:rPr>
                         <a:t>no</a:t>
@@ -3768,9 +3773,7 @@
                     </a:p>
                   </a:txBody>
                   <a:tcPr>
-                    <a:solidFill>
-                      <a:srgbClr val="FFFBE6"/>
-                    </a:solidFill>
+                    <a:noFill/>
                   </a:tcPr>
                 </a:tc>
                 <a:tc>
@@ -3780,10 +3783,7 @@
                     <a:p>
                       <a:pPr algn="ctr"/>
                       <a:r>
-                        <a:rPr sz="1400" b="1">
-                          <a:solidFill>
-                            <a:srgbClr val="B40000"/>
-                          </a:solidFill>
+                        <a:rPr sz="1400">
                           <a:latin typeface="Yu Gothic"/>
                         </a:rPr>
                         <a:t>no</a:t>
@@ -3791,9 +3791,7 @@
                     </a:p>
                   </a:txBody>
                   <a:tcPr>
-                    <a:solidFill>
-                      <a:srgbClr val="FFFBE6"/>
-                    </a:solidFill>
+                    <a:noFill/>
                   </a:tcPr>
                 </a:tc>
               </a:tr>

</xml_diff>

<commit_message>
Add borders to table cells on slide 8
Co-Authored-By: Claude Sonnet 4.6 <noreply@anthropic.com>
Claude-Session: https://claude.ai/code/session_017fvmJuBTTSQYZTwFUTf1rX
</commit_message>
<xml_diff>
--- a/public/slides_8_to_11.pptx
+++ b/public/slides_8_to_11.pptx
@@ -3168,6 +3168,26 @@
                   </a:txBody>
                   <a:tcPr>
                     <a:noFill/>
+                    <a:lnL w="12700">
+                      <a:solidFill>
+                        <a:srgbClr val="888888"/>
+                      </a:solidFill>
+                    </a:lnL>
+                    <a:lnR w="12700">
+                      <a:solidFill>
+                        <a:srgbClr val="888888"/>
+                      </a:solidFill>
+                    </a:lnR>
+                    <a:lnT w="12700">
+                      <a:solidFill>
+                        <a:srgbClr val="888888"/>
+                      </a:solidFill>
+                    </a:lnT>
+                    <a:lnB w="12700">
+                      <a:solidFill>
+                        <a:srgbClr val="888888"/>
+                      </a:solidFill>
+                    </a:lnB>
                   </a:tcPr>
                 </a:tc>
                 <a:tc>
@@ -3186,6 +3206,26 @@
                   </a:txBody>
                   <a:tcPr>
                     <a:noFill/>
+                    <a:lnL w="12700">
+                      <a:solidFill>
+                        <a:srgbClr val="888888"/>
+                      </a:solidFill>
+                    </a:lnL>
+                    <a:lnR w="12700">
+                      <a:solidFill>
+                        <a:srgbClr val="888888"/>
+                      </a:solidFill>
+                    </a:lnR>
+                    <a:lnT w="12700">
+                      <a:solidFill>
+                        <a:srgbClr val="888888"/>
+                      </a:solidFill>
+                    </a:lnT>
+                    <a:lnB w="12700">
+                      <a:solidFill>
+                        <a:srgbClr val="888888"/>
+                      </a:solidFill>
+                    </a:lnB>
                   </a:tcPr>
                 </a:tc>
                 <a:tc>
@@ -3204,6 +3244,26 @@
                   </a:txBody>
                   <a:tcPr>
                     <a:noFill/>
+                    <a:lnL w="12700">
+                      <a:solidFill>
+                        <a:srgbClr val="888888"/>
+                      </a:solidFill>
+                    </a:lnL>
+                    <a:lnR w="12700">
+                      <a:solidFill>
+                        <a:srgbClr val="888888"/>
+                      </a:solidFill>
+                    </a:lnR>
+                    <a:lnT w="12700">
+                      <a:solidFill>
+                        <a:srgbClr val="888888"/>
+                      </a:solidFill>
+                    </a:lnT>
+                    <a:lnB w="12700">
+                      <a:solidFill>
+                        <a:srgbClr val="888888"/>
+                      </a:solidFill>
+                    </a:lnB>
                   </a:tcPr>
                 </a:tc>
                 <a:tc>
@@ -3222,6 +3282,26 @@
                   </a:txBody>
                   <a:tcPr>
                     <a:noFill/>
+                    <a:lnL w="12700">
+                      <a:solidFill>
+                        <a:srgbClr val="888888"/>
+                      </a:solidFill>
+                    </a:lnL>
+                    <a:lnR w="12700">
+                      <a:solidFill>
+                        <a:srgbClr val="888888"/>
+                      </a:solidFill>
+                    </a:lnR>
+                    <a:lnT w="12700">
+                      <a:solidFill>
+                        <a:srgbClr val="888888"/>
+                      </a:solidFill>
+                    </a:lnT>
+                    <a:lnB w="12700">
+                      <a:solidFill>
+                        <a:srgbClr val="888888"/>
+                      </a:solidFill>
+                    </a:lnB>
                   </a:tcPr>
                 </a:tc>
                 <a:tc>
@@ -3240,6 +3320,26 @@
                   </a:txBody>
                   <a:tcPr>
                     <a:noFill/>
+                    <a:lnL w="12700">
+                      <a:solidFill>
+                        <a:srgbClr val="888888"/>
+                      </a:solidFill>
+                    </a:lnL>
+                    <a:lnR w="12700">
+                      <a:solidFill>
+                        <a:srgbClr val="888888"/>
+                      </a:solidFill>
+                    </a:lnR>
+                    <a:lnT w="12700">
+                      <a:solidFill>
+                        <a:srgbClr val="888888"/>
+                      </a:solidFill>
+                    </a:lnT>
+                    <a:lnB w="12700">
+                      <a:solidFill>
+                        <a:srgbClr val="888888"/>
+                      </a:solidFill>
+                    </a:lnB>
                   </a:tcPr>
                 </a:tc>
               </a:tr>
@@ -3260,6 +3360,26 @@
                   </a:txBody>
                   <a:tcPr>
                     <a:noFill/>
+                    <a:lnL w="12700">
+                      <a:solidFill>
+                        <a:srgbClr val="888888"/>
+                      </a:solidFill>
+                    </a:lnL>
+                    <a:lnR w="12700">
+                      <a:solidFill>
+                        <a:srgbClr val="888888"/>
+                      </a:solidFill>
+                    </a:lnR>
+                    <a:lnT w="12700">
+                      <a:solidFill>
+                        <a:srgbClr val="888888"/>
+                      </a:solidFill>
+                    </a:lnT>
+                    <a:lnB w="12700">
+                      <a:solidFill>
+                        <a:srgbClr val="888888"/>
+                      </a:solidFill>
+                    </a:lnB>
                   </a:tcPr>
                 </a:tc>
                 <a:tc>
@@ -3278,6 +3398,26 @@
                   </a:txBody>
                   <a:tcPr>
                     <a:noFill/>
+                    <a:lnL w="12700">
+                      <a:solidFill>
+                        <a:srgbClr val="888888"/>
+                      </a:solidFill>
+                    </a:lnL>
+                    <a:lnR w="12700">
+                      <a:solidFill>
+                        <a:srgbClr val="888888"/>
+                      </a:solidFill>
+                    </a:lnR>
+                    <a:lnT w="12700">
+                      <a:solidFill>
+                        <a:srgbClr val="888888"/>
+                      </a:solidFill>
+                    </a:lnT>
+                    <a:lnB w="12700">
+                      <a:solidFill>
+                        <a:srgbClr val="888888"/>
+                      </a:solidFill>
+                    </a:lnB>
                   </a:tcPr>
                 </a:tc>
                 <a:tc>
@@ -3296,6 +3436,26 @@
                   </a:txBody>
                   <a:tcPr>
                     <a:noFill/>
+                    <a:lnL w="12700">
+                      <a:solidFill>
+                        <a:srgbClr val="888888"/>
+                      </a:solidFill>
+                    </a:lnL>
+                    <a:lnR w="12700">
+                      <a:solidFill>
+                        <a:srgbClr val="888888"/>
+                      </a:solidFill>
+                    </a:lnR>
+                    <a:lnT w="12700">
+                      <a:solidFill>
+                        <a:srgbClr val="888888"/>
+                      </a:solidFill>
+                    </a:lnT>
+                    <a:lnB w="12700">
+                      <a:solidFill>
+                        <a:srgbClr val="888888"/>
+                      </a:solidFill>
+                    </a:lnB>
                   </a:tcPr>
                 </a:tc>
                 <a:tc>
@@ -3314,6 +3474,26 @@
                   </a:txBody>
                   <a:tcPr>
                     <a:noFill/>
+                    <a:lnL w="12700">
+                      <a:solidFill>
+                        <a:srgbClr val="888888"/>
+                      </a:solidFill>
+                    </a:lnL>
+                    <a:lnR w="12700">
+                      <a:solidFill>
+                        <a:srgbClr val="888888"/>
+                      </a:solidFill>
+                    </a:lnR>
+                    <a:lnT w="12700">
+                      <a:solidFill>
+                        <a:srgbClr val="888888"/>
+                      </a:solidFill>
+                    </a:lnT>
+                    <a:lnB w="12700">
+                      <a:solidFill>
+                        <a:srgbClr val="888888"/>
+                      </a:solidFill>
+                    </a:lnB>
                   </a:tcPr>
                 </a:tc>
                 <a:tc>
@@ -3332,6 +3512,26 @@
                   </a:txBody>
                   <a:tcPr>
                     <a:noFill/>
+                    <a:lnL w="12700">
+                      <a:solidFill>
+                        <a:srgbClr val="888888"/>
+                      </a:solidFill>
+                    </a:lnL>
+                    <a:lnR w="12700">
+                      <a:solidFill>
+                        <a:srgbClr val="888888"/>
+                      </a:solidFill>
+                    </a:lnR>
+                    <a:lnT w="12700">
+                      <a:solidFill>
+                        <a:srgbClr val="888888"/>
+                      </a:solidFill>
+                    </a:lnT>
+                    <a:lnB w="12700">
+                      <a:solidFill>
+                        <a:srgbClr val="888888"/>
+                      </a:solidFill>
+                    </a:lnB>
                   </a:tcPr>
                 </a:tc>
               </a:tr>
@@ -3352,6 +3552,26 @@
                   </a:txBody>
                   <a:tcPr>
                     <a:noFill/>
+                    <a:lnL w="12700">
+                      <a:solidFill>
+                        <a:srgbClr val="888888"/>
+                      </a:solidFill>
+                    </a:lnL>
+                    <a:lnR w="12700">
+                      <a:solidFill>
+                        <a:srgbClr val="888888"/>
+                      </a:solidFill>
+                    </a:lnR>
+                    <a:lnT w="12700">
+                      <a:solidFill>
+                        <a:srgbClr val="888888"/>
+                      </a:solidFill>
+                    </a:lnT>
+                    <a:lnB w="12700">
+                      <a:solidFill>
+                        <a:srgbClr val="888888"/>
+                      </a:solidFill>
+                    </a:lnB>
                   </a:tcPr>
                 </a:tc>
                 <a:tc>
@@ -3370,6 +3590,26 @@
                   </a:txBody>
                   <a:tcPr>
                     <a:noFill/>
+                    <a:lnL w="12700">
+                      <a:solidFill>
+                        <a:srgbClr val="888888"/>
+                      </a:solidFill>
+                    </a:lnL>
+                    <a:lnR w="12700">
+                      <a:solidFill>
+                        <a:srgbClr val="888888"/>
+                      </a:solidFill>
+                    </a:lnR>
+                    <a:lnT w="12700">
+                      <a:solidFill>
+                        <a:srgbClr val="888888"/>
+                      </a:solidFill>
+                    </a:lnT>
+                    <a:lnB w="12700">
+                      <a:solidFill>
+                        <a:srgbClr val="888888"/>
+                      </a:solidFill>
+                    </a:lnB>
                   </a:tcPr>
                 </a:tc>
                 <a:tc>
@@ -3388,6 +3628,26 @@
                   </a:txBody>
                   <a:tcPr>
                     <a:noFill/>
+                    <a:lnL w="12700">
+                      <a:solidFill>
+                        <a:srgbClr val="888888"/>
+                      </a:solidFill>
+                    </a:lnL>
+                    <a:lnR w="12700">
+                      <a:solidFill>
+                        <a:srgbClr val="888888"/>
+                      </a:solidFill>
+                    </a:lnR>
+                    <a:lnT w="12700">
+                      <a:solidFill>
+                        <a:srgbClr val="888888"/>
+                      </a:solidFill>
+                    </a:lnT>
+                    <a:lnB w="12700">
+                      <a:solidFill>
+                        <a:srgbClr val="888888"/>
+                      </a:solidFill>
+                    </a:lnB>
                   </a:tcPr>
                 </a:tc>
                 <a:tc>
@@ -3406,6 +3666,26 @@
                   </a:txBody>
                   <a:tcPr>
                     <a:noFill/>
+                    <a:lnL w="12700">
+                      <a:solidFill>
+                        <a:srgbClr val="888888"/>
+                      </a:solidFill>
+                    </a:lnL>
+                    <a:lnR w="12700">
+                      <a:solidFill>
+                        <a:srgbClr val="888888"/>
+                      </a:solidFill>
+                    </a:lnR>
+                    <a:lnT w="12700">
+                      <a:solidFill>
+                        <a:srgbClr val="888888"/>
+                      </a:solidFill>
+                    </a:lnT>
+                    <a:lnB w="12700">
+                      <a:solidFill>
+                        <a:srgbClr val="888888"/>
+                      </a:solidFill>
+                    </a:lnB>
                   </a:tcPr>
                 </a:tc>
                 <a:tc>
@@ -3424,6 +3704,26 @@
                   </a:txBody>
                   <a:tcPr>
                     <a:noFill/>
+                    <a:lnL w="12700">
+                      <a:solidFill>
+                        <a:srgbClr val="888888"/>
+                      </a:solidFill>
+                    </a:lnL>
+                    <a:lnR w="12700">
+                      <a:solidFill>
+                        <a:srgbClr val="888888"/>
+                      </a:solidFill>
+                    </a:lnR>
+                    <a:lnT w="12700">
+                      <a:solidFill>
+                        <a:srgbClr val="888888"/>
+                      </a:solidFill>
+                    </a:lnT>
+                    <a:lnB w="12700">
+                      <a:solidFill>
+                        <a:srgbClr val="888888"/>
+                      </a:solidFill>
+                    </a:lnB>
                   </a:tcPr>
                 </a:tc>
               </a:tr>
@@ -3444,6 +3744,26 @@
                   </a:txBody>
                   <a:tcPr>
                     <a:noFill/>
+                    <a:lnL w="12700">
+                      <a:solidFill>
+                        <a:srgbClr val="888888"/>
+                      </a:solidFill>
+                    </a:lnL>
+                    <a:lnR w="12700">
+                      <a:solidFill>
+                        <a:srgbClr val="888888"/>
+                      </a:solidFill>
+                    </a:lnR>
+                    <a:lnT w="12700">
+                      <a:solidFill>
+                        <a:srgbClr val="888888"/>
+                      </a:solidFill>
+                    </a:lnT>
+                    <a:lnB w="12700">
+                      <a:solidFill>
+                        <a:srgbClr val="888888"/>
+                      </a:solidFill>
+                    </a:lnB>
                   </a:tcPr>
                 </a:tc>
                 <a:tc>
@@ -3462,6 +3782,26 @@
                   </a:txBody>
                   <a:tcPr>
                     <a:noFill/>
+                    <a:lnL w="12700">
+                      <a:solidFill>
+                        <a:srgbClr val="888888"/>
+                      </a:solidFill>
+                    </a:lnL>
+                    <a:lnR w="12700">
+                      <a:solidFill>
+                        <a:srgbClr val="888888"/>
+                      </a:solidFill>
+                    </a:lnR>
+                    <a:lnT w="12700">
+                      <a:solidFill>
+                        <a:srgbClr val="888888"/>
+                      </a:solidFill>
+                    </a:lnT>
+                    <a:lnB w="12700">
+                      <a:solidFill>
+                        <a:srgbClr val="888888"/>
+                      </a:solidFill>
+                    </a:lnB>
                   </a:tcPr>
                 </a:tc>
                 <a:tc>
@@ -3480,6 +3820,26 @@
                   </a:txBody>
                   <a:tcPr>
                     <a:noFill/>
+                    <a:lnL w="12700">
+                      <a:solidFill>
+                        <a:srgbClr val="888888"/>
+                      </a:solidFill>
+                    </a:lnL>
+                    <a:lnR w="12700">
+                      <a:solidFill>
+                        <a:srgbClr val="888888"/>
+                      </a:solidFill>
+                    </a:lnR>
+                    <a:lnT w="12700">
+                      <a:solidFill>
+                        <a:srgbClr val="888888"/>
+                      </a:solidFill>
+                    </a:lnT>
+                    <a:lnB w="12700">
+                      <a:solidFill>
+                        <a:srgbClr val="888888"/>
+                      </a:solidFill>
+                    </a:lnB>
                   </a:tcPr>
                 </a:tc>
                 <a:tc>
@@ -3498,6 +3858,26 @@
                   </a:txBody>
                   <a:tcPr>
                     <a:noFill/>
+                    <a:lnL w="12700">
+                      <a:solidFill>
+                        <a:srgbClr val="888888"/>
+                      </a:solidFill>
+                    </a:lnL>
+                    <a:lnR w="12700">
+                      <a:solidFill>
+                        <a:srgbClr val="888888"/>
+                      </a:solidFill>
+                    </a:lnR>
+                    <a:lnT w="12700">
+                      <a:solidFill>
+                        <a:srgbClr val="888888"/>
+                      </a:solidFill>
+                    </a:lnT>
+                    <a:lnB w="12700">
+                      <a:solidFill>
+                        <a:srgbClr val="888888"/>
+                      </a:solidFill>
+                    </a:lnB>
                   </a:tcPr>
                 </a:tc>
                 <a:tc>
@@ -3516,6 +3896,26 @@
                   </a:txBody>
                   <a:tcPr>
                     <a:noFill/>
+                    <a:lnL w="12700">
+                      <a:solidFill>
+                        <a:srgbClr val="888888"/>
+                      </a:solidFill>
+                    </a:lnL>
+                    <a:lnR w="12700">
+                      <a:solidFill>
+                        <a:srgbClr val="888888"/>
+                      </a:solidFill>
+                    </a:lnR>
+                    <a:lnT w="12700">
+                      <a:solidFill>
+                        <a:srgbClr val="888888"/>
+                      </a:solidFill>
+                    </a:lnT>
+                    <a:lnB w="12700">
+                      <a:solidFill>
+                        <a:srgbClr val="888888"/>
+                      </a:solidFill>
+                    </a:lnB>
                   </a:tcPr>
                 </a:tc>
               </a:tr>
@@ -3536,6 +3936,26 @@
                   </a:txBody>
                   <a:tcPr>
                     <a:noFill/>
+                    <a:lnL w="12700">
+                      <a:solidFill>
+                        <a:srgbClr val="888888"/>
+                      </a:solidFill>
+                    </a:lnL>
+                    <a:lnR w="12700">
+                      <a:solidFill>
+                        <a:srgbClr val="888888"/>
+                      </a:solidFill>
+                    </a:lnR>
+                    <a:lnT w="12700">
+                      <a:solidFill>
+                        <a:srgbClr val="888888"/>
+                      </a:solidFill>
+                    </a:lnT>
+                    <a:lnB w="12700">
+                      <a:solidFill>
+                        <a:srgbClr val="888888"/>
+                      </a:solidFill>
+                    </a:lnB>
                   </a:tcPr>
                 </a:tc>
                 <a:tc>
@@ -3554,6 +3974,26 @@
                   </a:txBody>
                   <a:tcPr>
                     <a:noFill/>
+                    <a:lnL w="12700">
+                      <a:solidFill>
+                        <a:srgbClr val="888888"/>
+                      </a:solidFill>
+                    </a:lnL>
+                    <a:lnR w="12700">
+                      <a:solidFill>
+                        <a:srgbClr val="888888"/>
+                      </a:solidFill>
+                    </a:lnR>
+                    <a:lnT w="12700">
+                      <a:solidFill>
+                        <a:srgbClr val="888888"/>
+                      </a:solidFill>
+                    </a:lnT>
+                    <a:lnB w="12700">
+                      <a:solidFill>
+                        <a:srgbClr val="888888"/>
+                      </a:solidFill>
+                    </a:lnB>
                   </a:tcPr>
                 </a:tc>
                 <a:tc>
@@ -3572,6 +4012,26 @@
                   </a:txBody>
                   <a:tcPr>
                     <a:noFill/>
+                    <a:lnL w="12700">
+                      <a:solidFill>
+                        <a:srgbClr val="888888"/>
+                      </a:solidFill>
+                    </a:lnL>
+                    <a:lnR w="12700">
+                      <a:solidFill>
+                        <a:srgbClr val="888888"/>
+                      </a:solidFill>
+                    </a:lnR>
+                    <a:lnT w="12700">
+                      <a:solidFill>
+                        <a:srgbClr val="888888"/>
+                      </a:solidFill>
+                    </a:lnT>
+                    <a:lnB w="12700">
+                      <a:solidFill>
+                        <a:srgbClr val="888888"/>
+                      </a:solidFill>
+                    </a:lnB>
                   </a:tcPr>
                 </a:tc>
                 <a:tc>
@@ -3590,6 +4050,26 @@
                   </a:txBody>
                   <a:tcPr>
                     <a:noFill/>
+                    <a:lnL w="12700">
+                      <a:solidFill>
+                        <a:srgbClr val="888888"/>
+                      </a:solidFill>
+                    </a:lnL>
+                    <a:lnR w="12700">
+                      <a:solidFill>
+                        <a:srgbClr val="888888"/>
+                      </a:solidFill>
+                    </a:lnR>
+                    <a:lnT w="12700">
+                      <a:solidFill>
+                        <a:srgbClr val="888888"/>
+                      </a:solidFill>
+                    </a:lnT>
+                    <a:lnB w="12700">
+                      <a:solidFill>
+                        <a:srgbClr val="888888"/>
+                      </a:solidFill>
+                    </a:lnB>
                   </a:tcPr>
                 </a:tc>
                 <a:tc>
@@ -3608,6 +4088,26 @@
                   </a:txBody>
                   <a:tcPr>
                     <a:noFill/>
+                    <a:lnL w="12700">
+                      <a:solidFill>
+                        <a:srgbClr val="888888"/>
+                      </a:solidFill>
+                    </a:lnL>
+                    <a:lnR w="12700">
+                      <a:solidFill>
+                        <a:srgbClr val="888888"/>
+                      </a:solidFill>
+                    </a:lnR>
+                    <a:lnT w="12700">
+                      <a:solidFill>
+                        <a:srgbClr val="888888"/>
+                      </a:solidFill>
+                    </a:lnT>
+                    <a:lnB w="12700">
+                      <a:solidFill>
+                        <a:srgbClr val="888888"/>
+                      </a:solidFill>
+                    </a:lnB>
                   </a:tcPr>
                 </a:tc>
               </a:tr>
@@ -3628,6 +4128,26 @@
                   </a:txBody>
                   <a:tcPr>
                     <a:noFill/>
+                    <a:lnL w="12700">
+                      <a:solidFill>
+                        <a:srgbClr val="888888"/>
+                      </a:solidFill>
+                    </a:lnL>
+                    <a:lnR w="12700">
+                      <a:solidFill>
+                        <a:srgbClr val="888888"/>
+                      </a:solidFill>
+                    </a:lnR>
+                    <a:lnT w="12700">
+                      <a:solidFill>
+                        <a:srgbClr val="888888"/>
+                      </a:solidFill>
+                    </a:lnT>
+                    <a:lnB w="12700">
+                      <a:solidFill>
+                        <a:srgbClr val="888888"/>
+                      </a:solidFill>
+                    </a:lnB>
                   </a:tcPr>
                 </a:tc>
                 <a:tc>
@@ -3646,6 +4166,26 @@
                   </a:txBody>
                   <a:tcPr>
                     <a:noFill/>
+                    <a:lnL w="12700">
+                      <a:solidFill>
+                        <a:srgbClr val="888888"/>
+                      </a:solidFill>
+                    </a:lnL>
+                    <a:lnR w="12700">
+                      <a:solidFill>
+                        <a:srgbClr val="888888"/>
+                      </a:solidFill>
+                    </a:lnR>
+                    <a:lnT w="12700">
+                      <a:solidFill>
+                        <a:srgbClr val="888888"/>
+                      </a:solidFill>
+                    </a:lnT>
+                    <a:lnB w="12700">
+                      <a:solidFill>
+                        <a:srgbClr val="888888"/>
+                      </a:solidFill>
+                    </a:lnB>
                   </a:tcPr>
                 </a:tc>
                 <a:tc>
@@ -3664,6 +4204,26 @@
                   </a:txBody>
                   <a:tcPr>
                     <a:noFill/>
+                    <a:lnL w="12700">
+                      <a:solidFill>
+                        <a:srgbClr val="888888"/>
+                      </a:solidFill>
+                    </a:lnL>
+                    <a:lnR w="12700">
+                      <a:solidFill>
+                        <a:srgbClr val="888888"/>
+                      </a:solidFill>
+                    </a:lnR>
+                    <a:lnT w="12700">
+                      <a:solidFill>
+                        <a:srgbClr val="888888"/>
+                      </a:solidFill>
+                    </a:lnT>
+                    <a:lnB w="12700">
+                      <a:solidFill>
+                        <a:srgbClr val="888888"/>
+                      </a:solidFill>
+                    </a:lnB>
                   </a:tcPr>
                 </a:tc>
                 <a:tc>
@@ -3682,6 +4242,26 @@
                   </a:txBody>
                   <a:tcPr>
                     <a:noFill/>
+                    <a:lnL w="12700">
+                      <a:solidFill>
+                        <a:srgbClr val="888888"/>
+                      </a:solidFill>
+                    </a:lnL>
+                    <a:lnR w="12700">
+                      <a:solidFill>
+                        <a:srgbClr val="888888"/>
+                      </a:solidFill>
+                    </a:lnR>
+                    <a:lnT w="12700">
+                      <a:solidFill>
+                        <a:srgbClr val="888888"/>
+                      </a:solidFill>
+                    </a:lnT>
+                    <a:lnB w="12700">
+                      <a:solidFill>
+                        <a:srgbClr val="888888"/>
+                      </a:solidFill>
+                    </a:lnB>
                   </a:tcPr>
                 </a:tc>
                 <a:tc>
@@ -3700,6 +4280,26 @@
                   </a:txBody>
                   <a:tcPr>
                     <a:noFill/>
+                    <a:lnL w="12700">
+                      <a:solidFill>
+                        <a:srgbClr val="888888"/>
+                      </a:solidFill>
+                    </a:lnL>
+                    <a:lnR w="12700">
+                      <a:solidFill>
+                        <a:srgbClr val="888888"/>
+                      </a:solidFill>
+                    </a:lnR>
+                    <a:lnT w="12700">
+                      <a:solidFill>
+                        <a:srgbClr val="888888"/>
+                      </a:solidFill>
+                    </a:lnT>
+                    <a:lnB w="12700">
+                      <a:solidFill>
+                        <a:srgbClr val="888888"/>
+                      </a:solidFill>
+                    </a:lnB>
                   </a:tcPr>
                 </a:tc>
               </a:tr>
@@ -3720,6 +4320,26 @@
                   </a:txBody>
                   <a:tcPr>
                     <a:noFill/>
+                    <a:lnL w="12700">
+                      <a:solidFill>
+                        <a:srgbClr val="888888"/>
+                      </a:solidFill>
+                    </a:lnL>
+                    <a:lnR w="12700">
+                      <a:solidFill>
+                        <a:srgbClr val="888888"/>
+                      </a:solidFill>
+                    </a:lnR>
+                    <a:lnT w="12700">
+                      <a:solidFill>
+                        <a:srgbClr val="888888"/>
+                      </a:solidFill>
+                    </a:lnT>
+                    <a:lnB w="12700">
+                      <a:solidFill>
+                        <a:srgbClr val="888888"/>
+                      </a:solidFill>
+                    </a:lnB>
                   </a:tcPr>
                 </a:tc>
                 <a:tc>
@@ -3738,6 +4358,26 @@
                   </a:txBody>
                   <a:tcPr>
                     <a:noFill/>
+                    <a:lnL w="12700">
+                      <a:solidFill>
+                        <a:srgbClr val="888888"/>
+                      </a:solidFill>
+                    </a:lnL>
+                    <a:lnR w="12700">
+                      <a:solidFill>
+                        <a:srgbClr val="888888"/>
+                      </a:solidFill>
+                    </a:lnR>
+                    <a:lnT w="12700">
+                      <a:solidFill>
+                        <a:srgbClr val="888888"/>
+                      </a:solidFill>
+                    </a:lnT>
+                    <a:lnB w="12700">
+                      <a:solidFill>
+                        <a:srgbClr val="888888"/>
+                      </a:solidFill>
+                    </a:lnB>
                   </a:tcPr>
                 </a:tc>
                 <a:tc>
@@ -3756,6 +4396,26 @@
                   </a:txBody>
                   <a:tcPr>
                     <a:noFill/>
+                    <a:lnL w="12700">
+                      <a:solidFill>
+                        <a:srgbClr val="888888"/>
+                      </a:solidFill>
+                    </a:lnL>
+                    <a:lnR w="12700">
+                      <a:solidFill>
+                        <a:srgbClr val="888888"/>
+                      </a:solidFill>
+                    </a:lnR>
+                    <a:lnT w="12700">
+                      <a:solidFill>
+                        <a:srgbClr val="888888"/>
+                      </a:solidFill>
+                    </a:lnT>
+                    <a:lnB w="12700">
+                      <a:solidFill>
+                        <a:srgbClr val="888888"/>
+                      </a:solidFill>
+                    </a:lnB>
                   </a:tcPr>
                 </a:tc>
                 <a:tc>
@@ -3774,6 +4434,26 @@
                   </a:txBody>
                   <a:tcPr>
                     <a:noFill/>
+                    <a:lnL w="12700">
+                      <a:solidFill>
+                        <a:srgbClr val="888888"/>
+                      </a:solidFill>
+                    </a:lnL>
+                    <a:lnR w="12700">
+                      <a:solidFill>
+                        <a:srgbClr val="888888"/>
+                      </a:solidFill>
+                    </a:lnR>
+                    <a:lnT w="12700">
+                      <a:solidFill>
+                        <a:srgbClr val="888888"/>
+                      </a:solidFill>
+                    </a:lnT>
+                    <a:lnB w="12700">
+                      <a:solidFill>
+                        <a:srgbClr val="888888"/>
+                      </a:solidFill>
+                    </a:lnB>
                   </a:tcPr>
                 </a:tc>
                 <a:tc>
@@ -3792,6 +4472,26 @@
                   </a:txBody>
                   <a:tcPr>
                     <a:noFill/>
+                    <a:lnL w="12700">
+                      <a:solidFill>
+                        <a:srgbClr val="888888"/>
+                      </a:solidFill>
+                    </a:lnL>
+                    <a:lnR w="12700">
+                      <a:solidFill>
+                        <a:srgbClr val="888888"/>
+                      </a:solidFill>
+                    </a:lnR>
+                    <a:lnT w="12700">
+                      <a:solidFill>
+                        <a:srgbClr val="888888"/>
+                      </a:solidFill>
+                    </a:lnT>
+                    <a:lnB w="12700">
+                      <a:solidFill>
+                        <a:srgbClr val="888888"/>
+                      </a:solidFill>
+                    </a:lnB>
                   </a:tcPr>
                 </a:tc>
               </a:tr>

</xml_diff>

<commit_message>
Fix table borders by disabling default table style
Co-Authored-By: Claude Sonnet 4.6 <noreply@anthropic.com>
Claude-Session: https://claude.ai/code/session_017fvmJuBTTSQYZTwFUTf1rX
</commit_message>
<xml_diff>
--- a/public/slides_8_to_11.pptx
+++ b/public/slides_8_to_11.pptx
@@ -3142,7 +3142,7 @@
           <a:graphicData uri="http://schemas.openxmlformats.org/drawingml/2006/table">
             <a:tbl>
               <a:tblPr firstRow="1" bandRow="1">
-                <a:tableStyleId>{5C22544A-7EE6-4342-B048-85BDC9FD1C3A}</a:tableStyleId>
+                <a:tableStyleId>{00000000-0000-0000-0000-000000000000}</a:tableStyleId>
               </a:tblPr>
               <a:tblGrid>
                 <a:gridCol w="4114800"/>
@@ -3168,25 +3168,29 @@
                   </a:txBody>
                   <a:tcPr>
                     <a:noFill/>
-                    <a:lnL w="12700">
-                      <a:solidFill>
-                        <a:srgbClr val="888888"/>
-                      </a:solidFill>
+                    <a:lnL w="12700" cap="flat" cmpd="sng">
+                      <a:solidFill>
+                        <a:srgbClr val="000000"/>
+                      </a:solidFill>
+                      <a:prstDash val="solid"/>
                     </a:lnL>
-                    <a:lnR w="12700">
-                      <a:solidFill>
-                        <a:srgbClr val="888888"/>
-                      </a:solidFill>
+                    <a:lnR w="12700" cap="flat" cmpd="sng">
+                      <a:solidFill>
+                        <a:srgbClr val="000000"/>
+                      </a:solidFill>
+                      <a:prstDash val="solid"/>
                     </a:lnR>
-                    <a:lnT w="12700">
-                      <a:solidFill>
-                        <a:srgbClr val="888888"/>
-                      </a:solidFill>
+                    <a:lnT w="12700" cap="flat" cmpd="sng">
+                      <a:solidFill>
+                        <a:srgbClr val="000000"/>
+                      </a:solidFill>
+                      <a:prstDash val="solid"/>
                     </a:lnT>
-                    <a:lnB w="12700">
-                      <a:solidFill>
-                        <a:srgbClr val="888888"/>
-                      </a:solidFill>
+                    <a:lnB w="12700" cap="flat" cmpd="sng">
+                      <a:solidFill>
+                        <a:srgbClr val="000000"/>
+                      </a:solidFill>
+                      <a:prstDash val="solid"/>
                     </a:lnB>
                   </a:tcPr>
                 </a:tc>
@@ -3206,25 +3210,29 @@
                   </a:txBody>
                   <a:tcPr>
                     <a:noFill/>
-                    <a:lnL w="12700">
-                      <a:solidFill>
-                        <a:srgbClr val="888888"/>
-                      </a:solidFill>
+                    <a:lnL w="12700" cap="flat" cmpd="sng">
+                      <a:solidFill>
+                        <a:srgbClr val="000000"/>
+                      </a:solidFill>
+                      <a:prstDash val="solid"/>
                     </a:lnL>
-                    <a:lnR w="12700">
-                      <a:solidFill>
-                        <a:srgbClr val="888888"/>
-                      </a:solidFill>
+                    <a:lnR w="12700" cap="flat" cmpd="sng">
+                      <a:solidFill>
+                        <a:srgbClr val="000000"/>
+                      </a:solidFill>
+                      <a:prstDash val="solid"/>
                     </a:lnR>
-                    <a:lnT w="12700">
-                      <a:solidFill>
-                        <a:srgbClr val="888888"/>
-                      </a:solidFill>
+                    <a:lnT w="12700" cap="flat" cmpd="sng">
+                      <a:solidFill>
+                        <a:srgbClr val="000000"/>
+                      </a:solidFill>
+                      <a:prstDash val="solid"/>
                     </a:lnT>
-                    <a:lnB w="12700">
-                      <a:solidFill>
-                        <a:srgbClr val="888888"/>
-                      </a:solidFill>
+                    <a:lnB w="12700" cap="flat" cmpd="sng">
+                      <a:solidFill>
+                        <a:srgbClr val="000000"/>
+                      </a:solidFill>
+                      <a:prstDash val="solid"/>
                     </a:lnB>
                   </a:tcPr>
                 </a:tc>
@@ -3244,25 +3252,29 @@
                   </a:txBody>
                   <a:tcPr>
                     <a:noFill/>
-                    <a:lnL w="12700">
-                      <a:solidFill>
-                        <a:srgbClr val="888888"/>
-                      </a:solidFill>
+                    <a:lnL w="12700" cap="flat" cmpd="sng">
+                      <a:solidFill>
+                        <a:srgbClr val="000000"/>
+                      </a:solidFill>
+                      <a:prstDash val="solid"/>
                     </a:lnL>
-                    <a:lnR w="12700">
-                      <a:solidFill>
-                        <a:srgbClr val="888888"/>
-                      </a:solidFill>
+                    <a:lnR w="12700" cap="flat" cmpd="sng">
+                      <a:solidFill>
+                        <a:srgbClr val="000000"/>
+                      </a:solidFill>
+                      <a:prstDash val="solid"/>
                     </a:lnR>
-                    <a:lnT w="12700">
-                      <a:solidFill>
-                        <a:srgbClr val="888888"/>
-                      </a:solidFill>
+                    <a:lnT w="12700" cap="flat" cmpd="sng">
+                      <a:solidFill>
+                        <a:srgbClr val="000000"/>
+                      </a:solidFill>
+                      <a:prstDash val="solid"/>
                     </a:lnT>
-                    <a:lnB w="12700">
-                      <a:solidFill>
-                        <a:srgbClr val="888888"/>
-                      </a:solidFill>
+                    <a:lnB w="12700" cap="flat" cmpd="sng">
+                      <a:solidFill>
+                        <a:srgbClr val="000000"/>
+                      </a:solidFill>
+                      <a:prstDash val="solid"/>
                     </a:lnB>
                   </a:tcPr>
                 </a:tc>
@@ -3282,25 +3294,29 @@
                   </a:txBody>
                   <a:tcPr>
                     <a:noFill/>
-                    <a:lnL w="12700">
-                      <a:solidFill>
-                        <a:srgbClr val="888888"/>
-                      </a:solidFill>
+                    <a:lnL w="12700" cap="flat" cmpd="sng">
+                      <a:solidFill>
+                        <a:srgbClr val="000000"/>
+                      </a:solidFill>
+                      <a:prstDash val="solid"/>
                     </a:lnL>
-                    <a:lnR w="12700">
-                      <a:solidFill>
-                        <a:srgbClr val="888888"/>
-                      </a:solidFill>
+                    <a:lnR w="12700" cap="flat" cmpd="sng">
+                      <a:solidFill>
+                        <a:srgbClr val="000000"/>
+                      </a:solidFill>
+                      <a:prstDash val="solid"/>
                     </a:lnR>
-                    <a:lnT w="12700">
-                      <a:solidFill>
-                        <a:srgbClr val="888888"/>
-                      </a:solidFill>
+                    <a:lnT w="12700" cap="flat" cmpd="sng">
+                      <a:solidFill>
+                        <a:srgbClr val="000000"/>
+                      </a:solidFill>
+                      <a:prstDash val="solid"/>
                     </a:lnT>
-                    <a:lnB w="12700">
-                      <a:solidFill>
-                        <a:srgbClr val="888888"/>
-                      </a:solidFill>
+                    <a:lnB w="12700" cap="flat" cmpd="sng">
+                      <a:solidFill>
+                        <a:srgbClr val="000000"/>
+                      </a:solidFill>
+                      <a:prstDash val="solid"/>
                     </a:lnB>
                   </a:tcPr>
                 </a:tc>
@@ -3320,25 +3336,29 @@
                   </a:txBody>
                   <a:tcPr>
                     <a:noFill/>
-                    <a:lnL w="12700">
-                      <a:solidFill>
-                        <a:srgbClr val="888888"/>
-                      </a:solidFill>
+                    <a:lnL w="12700" cap="flat" cmpd="sng">
+                      <a:solidFill>
+                        <a:srgbClr val="000000"/>
+                      </a:solidFill>
+                      <a:prstDash val="solid"/>
                     </a:lnL>
-                    <a:lnR w="12700">
-                      <a:solidFill>
-                        <a:srgbClr val="888888"/>
-                      </a:solidFill>
+                    <a:lnR w="12700" cap="flat" cmpd="sng">
+                      <a:solidFill>
+                        <a:srgbClr val="000000"/>
+                      </a:solidFill>
+                      <a:prstDash val="solid"/>
                     </a:lnR>
-                    <a:lnT w="12700">
-                      <a:solidFill>
-                        <a:srgbClr val="888888"/>
-                      </a:solidFill>
+                    <a:lnT w="12700" cap="flat" cmpd="sng">
+                      <a:solidFill>
+                        <a:srgbClr val="000000"/>
+                      </a:solidFill>
+                      <a:prstDash val="solid"/>
                     </a:lnT>
-                    <a:lnB w="12700">
-                      <a:solidFill>
-                        <a:srgbClr val="888888"/>
-                      </a:solidFill>
+                    <a:lnB w="12700" cap="flat" cmpd="sng">
+                      <a:solidFill>
+                        <a:srgbClr val="000000"/>
+                      </a:solidFill>
+                      <a:prstDash val="solid"/>
                     </a:lnB>
                   </a:tcPr>
                 </a:tc>
@@ -3360,25 +3380,29 @@
                   </a:txBody>
                   <a:tcPr>
                     <a:noFill/>
-                    <a:lnL w="12700">
-                      <a:solidFill>
-                        <a:srgbClr val="888888"/>
-                      </a:solidFill>
+                    <a:lnL w="12700" cap="flat" cmpd="sng">
+                      <a:solidFill>
+                        <a:srgbClr val="000000"/>
+                      </a:solidFill>
+                      <a:prstDash val="solid"/>
                     </a:lnL>
-                    <a:lnR w="12700">
-                      <a:solidFill>
-                        <a:srgbClr val="888888"/>
-                      </a:solidFill>
+                    <a:lnR w="12700" cap="flat" cmpd="sng">
+                      <a:solidFill>
+                        <a:srgbClr val="000000"/>
+                      </a:solidFill>
+                      <a:prstDash val="solid"/>
                     </a:lnR>
-                    <a:lnT w="12700">
-                      <a:solidFill>
-                        <a:srgbClr val="888888"/>
-                      </a:solidFill>
+                    <a:lnT w="12700" cap="flat" cmpd="sng">
+                      <a:solidFill>
+                        <a:srgbClr val="000000"/>
+                      </a:solidFill>
+                      <a:prstDash val="solid"/>
                     </a:lnT>
-                    <a:lnB w="12700">
-                      <a:solidFill>
-                        <a:srgbClr val="888888"/>
-                      </a:solidFill>
+                    <a:lnB w="12700" cap="flat" cmpd="sng">
+                      <a:solidFill>
+                        <a:srgbClr val="000000"/>
+                      </a:solidFill>
+                      <a:prstDash val="solid"/>
                     </a:lnB>
                   </a:tcPr>
                 </a:tc>
@@ -3398,25 +3422,29 @@
                   </a:txBody>
                   <a:tcPr>
                     <a:noFill/>
-                    <a:lnL w="12700">
-                      <a:solidFill>
-                        <a:srgbClr val="888888"/>
-                      </a:solidFill>
+                    <a:lnL w="12700" cap="flat" cmpd="sng">
+                      <a:solidFill>
+                        <a:srgbClr val="000000"/>
+                      </a:solidFill>
+                      <a:prstDash val="solid"/>
                     </a:lnL>
-                    <a:lnR w="12700">
-                      <a:solidFill>
-                        <a:srgbClr val="888888"/>
-                      </a:solidFill>
+                    <a:lnR w="12700" cap="flat" cmpd="sng">
+                      <a:solidFill>
+                        <a:srgbClr val="000000"/>
+                      </a:solidFill>
+                      <a:prstDash val="solid"/>
                     </a:lnR>
-                    <a:lnT w="12700">
-                      <a:solidFill>
-                        <a:srgbClr val="888888"/>
-                      </a:solidFill>
+                    <a:lnT w="12700" cap="flat" cmpd="sng">
+                      <a:solidFill>
+                        <a:srgbClr val="000000"/>
+                      </a:solidFill>
+                      <a:prstDash val="solid"/>
                     </a:lnT>
-                    <a:lnB w="12700">
-                      <a:solidFill>
-                        <a:srgbClr val="888888"/>
-                      </a:solidFill>
+                    <a:lnB w="12700" cap="flat" cmpd="sng">
+                      <a:solidFill>
+                        <a:srgbClr val="000000"/>
+                      </a:solidFill>
+                      <a:prstDash val="solid"/>
                     </a:lnB>
                   </a:tcPr>
                 </a:tc>
@@ -3436,25 +3464,29 @@
                   </a:txBody>
                   <a:tcPr>
                     <a:noFill/>
-                    <a:lnL w="12700">
-                      <a:solidFill>
-                        <a:srgbClr val="888888"/>
-                      </a:solidFill>
+                    <a:lnL w="12700" cap="flat" cmpd="sng">
+                      <a:solidFill>
+                        <a:srgbClr val="000000"/>
+                      </a:solidFill>
+                      <a:prstDash val="solid"/>
                     </a:lnL>
-                    <a:lnR w="12700">
-                      <a:solidFill>
-                        <a:srgbClr val="888888"/>
-                      </a:solidFill>
+                    <a:lnR w="12700" cap="flat" cmpd="sng">
+                      <a:solidFill>
+                        <a:srgbClr val="000000"/>
+                      </a:solidFill>
+                      <a:prstDash val="solid"/>
                     </a:lnR>
-                    <a:lnT w="12700">
-                      <a:solidFill>
-                        <a:srgbClr val="888888"/>
-                      </a:solidFill>
+                    <a:lnT w="12700" cap="flat" cmpd="sng">
+                      <a:solidFill>
+                        <a:srgbClr val="000000"/>
+                      </a:solidFill>
+                      <a:prstDash val="solid"/>
                     </a:lnT>
-                    <a:lnB w="12700">
-                      <a:solidFill>
-                        <a:srgbClr val="888888"/>
-                      </a:solidFill>
+                    <a:lnB w="12700" cap="flat" cmpd="sng">
+                      <a:solidFill>
+                        <a:srgbClr val="000000"/>
+                      </a:solidFill>
+                      <a:prstDash val="solid"/>
                     </a:lnB>
                   </a:tcPr>
                 </a:tc>
@@ -3474,25 +3506,29 @@
                   </a:txBody>
                   <a:tcPr>
                     <a:noFill/>
-                    <a:lnL w="12700">
-                      <a:solidFill>
-                        <a:srgbClr val="888888"/>
-                      </a:solidFill>
+                    <a:lnL w="12700" cap="flat" cmpd="sng">
+                      <a:solidFill>
+                        <a:srgbClr val="000000"/>
+                      </a:solidFill>
+                      <a:prstDash val="solid"/>
                     </a:lnL>
-                    <a:lnR w="12700">
-                      <a:solidFill>
-                        <a:srgbClr val="888888"/>
-                      </a:solidFill>
+                    <a:lnR w="12700" cap="flat" cmpd="sng">
+                      <a:solidFill>
+                        <a:srgbClr val="000000"/>
+                      </a:solidFill>
+                      <a:prstDash val="solid"/>
                     </a:lnR>
-                    <a:lnT w="12700">
-                      <a:solidFill>
-                        <a:srgbClr val="888888"/>
-                      </a:solidFill>
+                    <a:lnT w="12700" cap="flat" cmpd="sng">
+                      <a:solidFill>
+                        <a:srgbClr val="000000"/>
+                      </a:solidFill>
+                      <a:prstDash val="solid"/>
                     </a:lnT>
-                    <a:lnB w="12700">
-                      <a:solidFill>
-                        <a:srgbClr val="888888"/>
-                      </a:solidFill>
+                    <a:lnB w="12700" cap="flat" cmpd="sng">
+                      <a:solidFill>
+                        <a:srgbClr val="000000"/>
+                      </a:solidFill>
+                      <a:prstDash val="solid"/>
                     </a:lnB>
                   </a:tcPr>
                 </a:tc>
@@ -3512,25 +3548,29 @@
                   </a:txBody>
                   <a:tcPr>
                     <a:noFill/>
-                    <a:lnL w="12700">
-                      <a:solidFill>
-                        <a:srgbClr val="888888"/>
-                      </a:solidFill>
+                    <a:lnL w="12700" cap="flat" cmpd="sng">
+                      <a:solidFill>
+                        <a:srgbClr val="000000"/>
+                      </a:solidFill>
+                      <a:prstDash val="solid"/>
                     </a:lnL>
-                    <a:lnR w="12700">
-                      <a:solidFill>
-                        <a:srgbClr val="888888"/>
-                      </a:solidFill>
+                    <a:lnR w="12700" cap="flat" cmpd="sng">
+                      <a:solidFill>
+                        <a:srgbClr val="000000"/>
+                      </a:solidFill>
+                      <a:prstDash val="solid"/>
                     </a:lnR>
-                    <a:lnT w="12700">
-                      <a:solidFill>
-                        <a:srgbClr val="888888"/>
-                      </a:solidFill>
+                    <a:lnT w="12700" cap="flat" cmpd="sng">
+                      <a:solidFill>
+                        <a:srgbClr val="000000"/>
+                      </a:solidFill>
+                      <a:prstDash val="solid"/>
                     </a:lnT>
-                    <a:lnB w="12700">
-                      <a:solidFill>
-                        <a:srgbClr val="888888"/>
-                      </a:solidFill>
+                    <a:lnB w="12700" cap="flat" cmpd="sng">
+                      <a:solidFill>
+                        <a:srgbClr val="000000"/>
+                      </a:solidFill>
+                      <a:prstDash val="solid"/>
                     </a:lnB>
                   </a:tcPr>
                 </a:tc>
@@ -3552,25 +3592,29 @@
                   </a:txBody>
                   <a:tcPr>
                     <a:noFill/>
-                    <a:lnL w="12700">
-                      <a:solidFill>
-                        <a:srgbClr val="888888"/>
-                      </a:solidFill>
+                    <a:lnL w="12700" cap="flat" cmpd="sng">
+                      <a:solidFill>
+                        <a:srgbClr val="000000"/>
+                      </a:solidFill>
+                      <a:prstDash val="solid"/>
                     </a:lnL>
-                    <a:lnR w="12700">
-                      <a:solidFill>
-                        <a:srgbClr val="888888"/>
-                      </a:solidFill>
+                    <a:lnR w="12700" cap="flat" cmpd="sng">
+                      <a:solidFill>
+                        <a:srgbClr val="000000"/>
+                      </a:solidFill>
+                      <a:prstDash val="solid"/>
                     </a:lnR>
-                    <a:lnT w="12700">
-                      <a:solidFill>
-                        <a:srgbClr val="888888"/>
-                      </a:solidFill>
+                    <a:lnT w="12700" cap="flat" cmpd="sng">
+                      <a:solidFill>
+                        <a:srgbClr val="000000"/>
+                      </a:solidFill>
+                      <a:prstDash val="solid"/>
                     </a:lnT>
-                    <a:lnB w="12700">
-                      <a:solidFill>
-                        <a:srgbClr val="888888"/>
-                      </a:solidFill>
+                    <a:lnB w="12700" cap="flat" cmpd="sng">
+                      <a:solidFill>
+                        <a:srgbClr val="000000"/>
+                      </a:solidFill>
+                      <a:prstDash val="solid"/>
                     </a:lnB>
                   </a:tcPr>
                 </a:tc>
@@ -3590,25 +3634,29 @@
                   </a:txBody>
                   <a:tcPr>
                     <a:noFill/>
-                    <a:lnL w="12700">
-                      <a:solidFill>
-                        <a:srgbClr val="888888"/>
-                      </a:solidFill>
+                    <a:lnL w="12700" cap="flat" cmpd="sng">
+                      <a:solidFill>
+                        <a:srgbClr val="000000"/>
+                      </a:solidFill>
+                      <a:prstDash val="solid"/>
                     </a:lnL>
-                    <a:lnR w="12700">
-                      <a:solidFill>
-                        <a:srgbClr val="888888"/>
-                      </a:solidFill>
+                    <a:lnR w="12700" cap="flat" cmpd="sng">
+                      <a:solidFill>
+                        <a:srgbClr val="000000"/>
+                      </a:solidFill>
+                      <a:prstDash val="solid"/>
                     </a:lnR>
-                    <a:lnT w="12700">
-                      <a:solidFill>
-                        <a:srgbClr val="888888"/>
-                      </a:solidFill>
+                    <a:lnT w="12700" cap="flat" cmpd="sng">
+                      <a:solidFill>
+                        <a:srgbClr val="000000"/>
+                      </a:solidFill>
+                      <a:prstDash val="solid"/>
                     </a:lnT>
-                    <a:lnB w="12700">
-                      <a:solidFill>
-                        <a:srgbClr val="888888"/>
-                      </a:solidFill>
+                    <a:lnB w="12700" cap="flat" cmpd="sng">
+                      <a:solidFill>
+                        <a:srgbClr val="000000"/>
+                      </a:solidFill>
+                      <a:prstDash val="solid"/>
                     </a:lnB>
                   </a:tcPr>
                 </a:tc>
@@ -3628,25 +3676,29 @@
                   </a:txBody>
                   <a:tcPr>
                     <a:noFill/>
-                    <a:lnL w="12700">
-                      <a:solidFill>
-                        <a:srgbClr val="888888"/>
-                      </a:solidFill>
+                    <a:lnL w="12700" cap="flat" cmpd="sng">
+                      <a:solidFill>
+                        <a:srgbClr val="000000"/>
+                      </a:solidFill>
+                      <a:prstDash val="solid"/>
                     </a:lnL>
-                    <a:lnR w="12700">
-                      <a:solidFill>
-                        <a:srgbClr val="888888"/>
-                      </a:solidFill>
+                    <a:lnR w="12700" cap="flat" cmpd="sng">
+                      <a:solidFill>
+                        <a:srgbClr val="000000"/>
+                      </a:solidFill>
+                      <a:prstDash val="solid"/>
                     </a:lnR>
-                    <a:lnT w="12700">
-                      <a:solidFill>
-                        <a:srgbClr val="888888"/>
-                      </a:solidFill>
+                    <a:lnT w="12700" cap="flat" cmpd="sng">
+                      <a:solidFill>
+                        <a:srgbClr val="000000"/>
+                      </a:solidFill>
+                      <a:prstDash val="solid"/>
                     </a:lnT>
-                    <a:lnB w="12700">
-                      <a:solidFill>
-                        <a:srgbClr val="888888"/>
-                      </a:solidFill>
+                    <a:lnB w="12700" cap="flat" cmpd="sng">
+                      <a:solidFill>
+                        <a:srgbClr val="000000"/>
+                      </a:solidFill>
+                      <a:prstDash val="solid"/>
                     </a:lnB>
                   </a:tcPr>
                 </a:tc>
@@ -3666,25 +3718,29 @@
                   </a:txBody>
                   <a:tcPr>
                     <a:noFill/>
-                    <a:lnL w="12700">
-                      <a:solidFill>
-                        <a:srgbClr val="888888"/>
-                      </a:solidFill>
+                    <a:lnL w="12700" cap="flat" cmpd="sng">
+                      <a:solidFill>
+                        <a:srgbClr val="000000"/>
+                      </a:solidFill>
+                      <a:prstDash val="solid"/>
                     </a:lnL>
-                    <a:lnR w="12700">
-                      <a:solidFill>
-                        <a:srgbClr val="888888"/>
-                      </a:solidFill>
+                    <a:lnR w="12700" cap="flat" cmpd="sng">
+                      <a:solidFill>
+                        <a:srgbClr val="000000"/>
+                      </a:solidFill>
+                      <a:prstDash val="solid"/>
                     </a:lnR>
-                    <a:lnT w="12700">
-                      <a:solidFill>
-                        <a:srgbClr val="888888"/>
-                      </a:solidFill>
+                    <a:lnT w="12700" cap="flat" cmpd="sng">
+                      <a:solidFill>
+                        <a:srgbClr val="000000"/>
+                      </a:solidFill>
+                      <a:prstDash val="solid"/>
                     </a:lnT>
-                    <a:lnB w="12700">
-                      <a:solidFill>
-                        <a:srgbClr val="888888"/>
-                      </a:solidFill>
+                    <a:lnB w="12700" cap="flat" cmpd="sng">
+                      <a:solidFill>
+                        <a:srgbClr val="000000"/>
+                      </a:solidFill>
+                      <a:prstDash val="solid"/>
                     </a:lnB>
                   </a:tcPr>
                 </a:tc>
@@ -3704,25 +3760,29 @@
                   </a:txBody>
                   <a:tcPr>
                     <a:noFill/>
-                    <a:lnL w="12700">
-                      <a:solidFill>
-                        <a:srgbClr val="888888"/>
-                      </a:solidFill>
+                    <a:lnL w="12700" cap="flat" cmpd="sng">
+                      <a:solidFill>
+                        <a:srgbClr val="000000"/>
+                      </a:solidFill>
+                      <a:prstDash val="solid"/>
                     </a:lnL>
-                    <a:lnR w="12700">
-                      <a:solidFill>
-                        <a:srgbClr val="888888"/>
-                      </a:solidFill>
+                    <a:lnR w="12700" cap="flat" cmpd="sng">
+                      <a:solidFill>
+                        <a:srgbClr val="000000"/>
+                      </a:solidFill>
+                      <a:prstDash val="solid"/>
                     </a:lnR>
-                    <a:lnT w="12700">
-                      <a:solidFill>
-                        <a:srgbClr val="888888"/>
-                      </a:solidFill>
+                    <a:lnT w="12700" cap="flat" cmpd="sng">
+                      <a:solidFill>
+                        <a:srgbClr val="000000"/>
+                      </a:solidFill>
+                      <a:prstDash val="solid"/>
                     </a:lnT>
-                    <a:lnB w="12700">
-                      <a:solidFill>
-                        <a:srgbClr val="888888"/>
-                      </a:solidFill>
+                    <a:lnB w="12700" cap="flat" cmpd="sng">
+                      <a:solidFill>
+                        <a:srgbClr val="000000"/>
+                      </a:solidFill>
+                      <a:prstDash val="solid"/>
                     </a:lnB>
                   </a:tcPr>
                 </a:tc>
@@ -3744,25 +3804,29 @@
                   </a:txBody>
                   <a:tcPr>
                     <a:noFill/>
-                    <a:lnL w="12700">
-                      <a:solidFill>
-                        <a:srgbClr val="888888"/>
-                      </a:solidFill>
+                    <a:lnL w="12700" cap="flat" cmpd="sng">
+                      <a:solidFill>
+                        <a:srgbClr val="000000"/>
+                      </a:solidFill>
+                      <a:prstDash val="solid"/>
                     </a:lnL>
-                    <a:lnR w="12700">
-                      <a:solidFill>
-                        <a:srgbClr val="888888"/>
-                      </a:solidFill>
+                    <a:lnR w="12700" cap="flat" cmpd="sng">
+                      <a:solidFill>
+                        <a:srgbClr val="000000"/>
+                      </a:solidFill>
+                      <a:prstDash val="solid"/>
                     </a:lnR>
-                    <a:lnT w="12700">
-                      <a:solidFill>
-                        <a:srgbClr val="888888"/>
-                      </a:solidFill>
+                    <a:lnT w="12700" cap="flat" cmpd="sng">
+                      <a:solidFill>
+                        <a:srgbClr val="000000"/>
+                      </a:solidFill>
+                      <a:prstDash val="solid"/>
                     </a:lnT>
-                    <a:lnB w="12700">
-                      <a:solidFill>
-                        <a:srgbClr val="888888"/>
-                      </a:solidFill>
+                    <a:lnB w="12700" cap="flat" cmpd="sng">
+                      <a:solidFill>
+                        <a:srgbClr val="000000"/>
+                      </a:solidFill>
+                      <a:prstDash val="solid"/>
                     </a:lnB>
                   </a:tcPr>
                 </a:tc>
@@ -3782,25 +3846,29 @@
                   </a:txBody>
                   <a:tcPr>
                     <a:noFill/>
-                    <a:lnL w="12700">
-                      <a:solidFill>
-                        <a:srgbClr val="888888"/>
-                      </a:solidFill>
+                    <a:lnL w="12700" cap="flat" cmpd="sng">
+                      <a:solidFill>
+                        <a:srgbClr val="000000"/>
+                      </a:solidFill>
+                      <a:prstDash val="solid"/>
                     </a:lnL>
-                    <a:lnR w="12700">
-                      <a:solidFill>
-                        <a:srgbClr val="888888"/>
-                      </a:solidFill>
+                    <a:lnR w="12700" cap="flat" cmpd="sng">
+                      <a:solidFill>
+                        <a:srgbClr val="000000"/>
+                      </a:solidFill>
+                      <a:prstDash val="solid"/>
                     </a:lnR>
-                    <a:lnT w="12700">
-                      <a:solidFill>
-                        <a:srgbClr val="888888"/>
-                      </a:solidFill>
+                    <a:lnT w="12700" cap="flat" cmpd="sng">
+                      <a:solidFill>
+                        <a:srgbClr val="000000"/>
+                      </a:solidFill>
+                      <a:prstDash val="solid"/>
                     </a:lnT>
-                    <a:lnB w="12700">
-                      <a:solidFill>
-                        <a:srgbClr val="888888"/>
-                      </a:solidFill>
+                    <a:lnB w="12700" cap="flat" cmpd="sng">
+                      <a:solidFill>
+                        <a:srgbClr val="000000"/>
+                      </a:solidFill>
+                      <a:prstDash val="solid"/>
                     </a:lnB>
                   </a:tcPr>
                 </a:tc>
@@ -3820,25 +3888,29 @@
                   </a:txBody>
                   <a:tcPr>
                     <a:noFill/>
-                    <a:lnL w="12700">
-                      <a:solidFill>
-                        <a:srgbClr val="888888"/>
-                      </a:solidFill>
+                    <a:lnL w="12700" cap="flat" cmpd="sng">
+                      <a:solidFill>
+                        <a:srgbClr val="000000"/>
+                      </a:solidFill>
+                      <a:prstDash val="solid"/>
                     </a:lnL>
-                    <a:lnR w="12700">
-                      <a:solidFill>
-                        <a:srgbClr val="888888"/>
-                      </a:solidFill>
+                    <a:lnR w="12700" cap="flat" cmpd="sng">
+                      <a:solidFill>
+                        <a:srgbClr val="000000"/>
+                      </a:solidFill>
+                      <a:prstDash val="solid"/>
                     </a:lnR>
-                    <a:lnT w="12700">
-                      <a:solidFill>
-                        <a:srgbClr val="888888"/>
-                      </a:solidFill>
+                    <a:lnT w="12700" cap="flat" cmpd="sng">
+                      <a:solidFill>
+                        <a:srgbClr val="000000"/>
+                      </a:solidFill>
+                      <a:prstDash val="solid"/>
                     </a:lnT>
-                    <a:lnB w="12700">
-                      <a:solidFill>
-                        <a:srgbClr val="888888"/>
-                      </a:solidFill>
+                    <a:lnB w="12700" cap="flat" cmpd="sng">
+                      <a:solidFill>
+                        <a:srgbClr val="000000"/>
+                      </a:solidFill>
+                      <a:prstDash val="solid"/>
                     </a:lnB>
                   </a:tcPr>
                 </a:tc>
@@ -3858,25 +3930,29 @@
                   </a:txBody>
                   <a:tcPr>
                     <a:noFill/>
-                    <a:lnL w="12700">
-                      <a:solidFill>
-                        <a:srgbClr val="888888"/>
-                      </a:solidFill>
+                    <a:lnL w="12700" cap="flat" cmpd="sng">
+                      <a:solidFill>
+                        <a:srgbClr val="000000"/>
+                      </a:solidFill>
+                      <a:prstDash val="solid"/>
                     </a:lnL>
-                    <a:lnR w="12700">
-                      <a:solidFill>
-                        <a:srgbClr val="888888"/>
-                      </a:solidFill>
+                    <a:lnR w="12700" cap="flat" cmpd="sng">
+                      <a:solidFill>
+                        <a:srgbClr val="000000"/>
+                      </a:solidFill>
+                      <a:prstDash val="solid"/>
                     </a:lnR>
-                    <a:lnT w="12700">
-                      <a:solidFill>
-                        <a:srgbClr val="888888"/>
-                      </a:solidFill>
+                    <a:lnT w="12700" cap="flat" cmpd="sng">
+                      <a:solidFill>
+                        <a:srgbClr val="000000"/>
+                      </a:solidFill>
+                      <a:prstDash val="solid"/>
                     </a:lnT>
-                    <a:lnB w="12700">
-                      <a:solidFill>
-                        <a:srgbClr val="888888"/>
-                      </a:solidFill>
+                    <a:lnB w="12700" cap="flat" cmpd="sng">
+                      <a:solidFill>
+                        <a:srgbClr val="000000"/>
+                      </a:solidFill>
+                      <a:prstDash val="solid"/>
                     </a:lnB>
                   </a:tcPr>
                 </a:tc>
@@ -3896,25 +3972,29 @@
                   </a:txBody>
                   <a:tcPr>
                     <a:noFill/>
-                    <a:lnL w="12700">
-                      <a:solidFill>
-                        <a:srgbClr val="888888"/>
-                      </a:solidFill>
+                    <a:lnL w="12700" cap="flat" cmpd="sng">
+                      <a:solidFill>
+                        <a:srgbClr val="000000"/>
+                      </a:solidFill>
+                      <a:prstDash val="solid"/>
                     </a:lnL>
-                    <a:lnR w="12700">
-                      <a:solidFill>
-                        <a:srgbClr val="888888"/>
-                      </a:solidFill>
+                    <a:lnR w="12700" cap="flat" cmpd="sng">
+                      <a:solidFill>
+                        <a:srgbClr val="000000"/>
+                      </a:solidFill>
+                      <a:prstDash val="solid"/>
                     </a:lnR>
-                    <a:lnT w="12700">
-                      <a:solidFill>
-                        <a:srgbClr val="888888"/>
-                      </a:solidFill>
+                    <a:lnT w="12700" cap="flat" cmpd="sng">
+                      <a:solidFill>
+                        <a:srgbClr val="000000"/>
+                      </a:solidFill>
+                      <a:prstDash val="solid"/>
                     </a:lnT>
-                    <a:lnB w="12700">
-                      <a:solidFill>
-                        <a:srgbClr val="888888"/>
-                      </a:solidFill>
+                    <a:lnB w="12700" cap="flat" cmpd="sng">
+                      <a:solidFill>
+                        <a:srgbClr val="000000"/>
+                      </a:solidFill>
+                      <a:prstDash val="solid"/>
                     </a:lnB>
                   </a:tcPr>
                 </a:tc>
@@ -3936,25 +4016,29 @@
                   </a:txBody>
                   <a:tcPr>
                     <a:noFill/>
-                    <a:lnL w="12700">
-                      <a:solidFill>
-                        <a:srgbClr val="888888"/>
-                      </a:solidFill>
+                    <a:lnL w="12700" cap="flat" cmpd="sng">
+                      <a:solidFill>
+                        <a:srgbClr val="000000"/>
+                      </a:solidFill>
+                      <a:prstDash val="solid"/>
                     </a:lnL>
-                    <a:lnR w="12700">
-                      <a:solidFill>
-                        <a:srgbClr val="888888"/>
-                      </a:solidFill>
+                    <a:lnR w="12700" cap="flat" cmpd="sng">
+                      <a:solidFill>
+                        <a:srgbClr val="000000"/>
+                      </a:solidFill>
+                      <a:prstDash val="solid"/>
                     </a:lnR>
-                    <a:lnT w="12700">
-                      <a:solidFill>
-                        <a:srgbClr val="888888"/>
-                      </a:solidFill>
+                    <a:lnT w="12700" cap="flat" cmpd="sng">
+                      <a:solidFill>
+                        <a:srgbClr val="000000"/>
+                      </a:solidFill>
+                      <a:prstDash val="solid"/>
                     </a:lnT>
-                    <a:lnB w="12700">
-                      <a:solidFill>
-                        <a:srgbClr val="888888"/>
-                      </a:solidFill>
+                    <a:lnB w="12700" cap="flat" cmpd="sng">
+                      <a:solidFill>
+                        <a:srgbClr val="000000"/>
+                      </a:solidFill>
+                      <a:prstDash val="solid"/>
                     </a:lnB>
                   </a:tcPr>
                 </a:tc>
@@ -3974,25 +4058,29 @@
                   </a:txBody>
                   <a:tcPr>
                     <a:noFill/>
-                    <a:lnL w="12700">
-                      <a:solidFill>
-                        <a:srgbClr val="888888"/>
-                      </a:solidFill>
+                    <a:lnL w="12700" cap="flat" cmpd="sng">
+                      <a:solidFill>
+                        <a:srgbClr val="000000"/>
+                      </a:solidFill>
+                      <a:prstDash val="solid"/>
                     </a:lnL>
-                    <a:lnR w="12700">
-                      <a:solidFill>
-                        <a:srgbClr val="888888"/>
-                      </a:solidFill>
+                    <a:lnR w="12700" cap="flat" cmpd="sng">
+                      <a:solidFill>
+                        <a:srgbClr val="000000"/>
+                      </a:solidFill>
+                      <a:prstDash val="solid"/>
                     </a:lnR>
-                    <a:lnT w="12700">
-                      <a:solidFill>
-                        <a:srgbClr val="888888"/>
-                      </a:solidFill>
+                    <a:lnT w="12700" cap="flat" cmpd="sng">
+                      <a:solidFill>
+                        <a:srgbClr val="000000"/>
+                      </a:solidFill>
+                      <a:prstDash val="solid"/>
                     </a:lnT>
-                    <a:lnB w="12700">
-                      <a:solidFill>
-                        <a:srgbClr val="888888"/>
-                      </a:solidFill>
+                    <a:lnB w="12700" cap="flat" cmpd="sng">
+                      <a:solidFill>
+                        <a:srgbClr val="000000"/>
+                      </a:solidFill>
+                      <a:prstDash val="solid"/>
                     </a:lnB>
                   </a:tcPr>
                 </a:tc>
@@ -4012,25 +4100,29 @@
                   </a:txBody>
                   <a:tcPr>
                     <a:noFill/>
-                    <a:lnL w="12700">
-                      <a:solidFill>
-                        <a:srgbClr val="888888"/>
-                      </a:solidFill>
+                    <a:lnL w="12700" cap="flat" cmpd="sng">
+                      <a:solidFill>
+                        <a:srgbClr val="000000"/>
+                      </a:solidFill>
+                      <a:prstDash val="solid"/>
                     </a:lnL>
-                    <a:lnR w="12700">
-                      <a:solidFill>
-                        <a:srgbClr val="888888"/>
-                      </a:solidFill>
+                    <a:lnR w="12700" cap="flat" cmpd="sng">
+                      <a:solidFill>
+                        <a:srgbClr val="000000"/>
+                      </a:solidFill>
+                      <a:prstDash val="solid"/>
                     </a:lnR>
-                    <a:lnT w="12700">
-                      <a:solidFill>
-                        <a:srgbClr val="888888"/>
-                      </a:solidFill>
+                    <a:lnT w="12700" cap="flat" cmpd="sng">
+                      <a:solidFill>
+                        <a:srgbClr val="000000"/>
+                      </a:solidFill>
+                      <a:prstDash val="solid"/>
                     </a:lnT>
-                    <a:lnB w="12700">
-                      <a:solidFill>
-                        <a:srgbClr val="888888"/>
-                      </a:solidFill>
+                    <a:lnB w="12700" cap="flat" cmpd="sng">
+                      <a:solidFill>
+                        <a:srgbClr val="000000"/>
+                      </a:solidFill>
+                      <a:prstDash val="solid"/>
                     </a:lnB>
                   </a:tcPr>
                 </a:tc>
@@ -4050,25 +4142,29 @@
                   </a:txBody>
                   <a:tcPr>
                     <a:noFill/>
-                    <a:lnL w="12700">
-                      <a:solidFill>
-                        <a:srgbClr val="888888"/>
-                      </a:solidFill>
+                    <a:lnL w="12700" cap="flat" cmpd="sng">
+                      <a:solidFill>
+                        <a:srgbClr val="000000"/>
+                      </a:solidFill>
+                      <a:prstDash val="solid"/>
                     </a:lnL>
-                    <a:lnR w="12700">
-                      <a:solidFill>
-                        <a:srgbClr val="888888"/>
-                      </a:solidFill>
+                    <a:lnR w="12700" cap="flat" cmpd="sng">
+                      <a:solidFill>
+                        <a:srgbClr val="000000"/>
+                      </a:solidFill>
+                      <a:prstDash val="solid"/>
                     </a:lnR>
-                    <a:lnT w="12700">
-                      <a:solidFill>
-                        <a:srgbClr val="888888"/>
-                      </a:solidFill>
+                    <a:lnT w="12700" cap="flat" cmpd="sng">
+                      <a:solidFill>
+                        <a:srgbClr val="000000"/>
+                      </a:solidFill>
+                      <a:prstDash val="solid"/>
                     </a:lnT>
-                    <a:lnB w="12700">
-                      <a:solidFill>
-                        <a:srgbClr val="888888"/>
-                      </a:solidFill>
+                    <a:lnB w="12700" cap="flat" cmpd="sng">
+                      <a:solidFill>
+                        <a:srgbClr val="000000"/>
+                      </a:solidFill>
+                      <a:prstDash val="solid"/>
                     </a:lnB>
                   </a:tcPr>
                 </a:tc>
@@ -4088,25 +4184,29 @@
                   </a:txBody>
                   <a:tcPr>
                     <a:noFill/>
-                    <a:lnL w="12700">
-                      <a:solidFill>
-                        <a:srgbClr val="888888"/>
-                      </a:solidFill>
+                    <a:lnL w="12700" cap="flat" cmpd="sng">
+                      <a:solidFill>
+                        <a:srgbClr val="000000"/>
+                      </a:solidFill>
+                      <a:prstDash val="solid"/>
                     </a:lnL>
-                    <a:lnR w="12700">
-                      <a:solidFill>
-                        <a:srgbClr val="888888"/>
-                      </a:solidFill>
+                    <a:lnR w="12700" cap="flat" cmpd="sng">
+                      <a:solidFill>
+                        <a:srgbClr val="000000"/>
+                      </a:solidFill>
+                      <a:prstDash val="solid"/>
                     </a:lnR>
-                    <a:lnT w="12700">
-                      <a:solidFill>
-                        <a:srgbClr val="888888"/>
-                      </a:solidFill>
+                    <a:lnT w="12700" cap="flat" cmpd="sng">
+                      <a:solidFill>
+                        <a:srgbClr val="000000"/>
+                      </a:solidFill>
+                      <a:prstDash val="solid"/>
                     </a:lnT>
-                    <a:lnB w="12700">
-                      <a:solidFill>
-                        <a:srgbClr val="888888"/>
-                      </a:solidFill>
+                    <a:lnB w="12700" cap="flat" cmpd="sng">
+                      <a:solidFill>
+                        <a:srgbClr val="000000"/>
+                      </a:solidFill>
+                      <a:prstDash val="solid"/>
                     </a:lnB>
                   </a:tcPr>
                 </a:tc>
@@ -4128,25 +4228,29 @@
                   </a:txBody>
                   <a:tcPr>
                     <a:noFill/>
-                    <a:lnL w="12700">
-                      <a:solidFill>
-                        <a:srgbClr val="888888"/>
-                      </a:solidFill>
+                    <a:lnL w="12700" cap="flat" cmpd="sng">
+                      <a:solidFill>
+                        <a:srgbClr val="000000"/>
+                      </a:solidFill>
+                      <a:prstDash val="solid"/>
                     </a:lnL>
-                    <a:lnR w="12700">
-                      <a:solidFill>
-                        <a:srgbClr val="888888"/>
-                      </a:solidFill>
+                    <a:lnR w="12700" cap="flat" cmpd="sng">
+                      <a:solidFill>
+                        <a:srgbClr val="000000"/>
+                      </a:solidFill>
+                      <a:prstDash val="solid"/>
                     </a:lnR>
-                    <a:lnT w="12700">
-                      <a:solidFill>
-                        <a:srgbClr val="888888"/>
-                      </a:solidFill>
+                    <a:lnT w="12700" cap="flat" cmpd="sng">
+                      <a:solidFill>
+                        <a:srgbClr val="000000"/>
+                      </a:solidFill>
+                      <a:prstDash val="solid"/>
                     </a:lnT>
-                    <a:lnB w="12700">
-                      <a:solidFill>
-                        <a:srgbClr val="888888"/>
-                      </a:solidFill>
+                    <a:lnB w="12700" cap="flat" cmpd="sng">
+                      <a:solidFill>
+                        <a:srgbClr val="000000"/>
+                      </a:solidFill>
+                      <a:prstDash val="solid"/>
                     </a:lnB>
                   </a:tcPr>
                 </a:tc>
@@ -4166,25 +4270,29 @@
                   </a:txBody>
                   <a:tcPr>
                     <a:noFill/>
-                    <a:lnL w="12700">
-                      <a:solidFill>
-                        <a:srgbClr val="888888"/>
-                      </a:solidFill>
+                    <a:lnL w="12700" cap="flat" cmpd="sng">
+                      <a:solidFill>
+                        <a:srgbClr val="000000"/>
+                      </a:solidFill>
+                      <a:prstDash val="solid"/>
                     </a:lnL>
-                    <a:lnR w="12700">
-                      <a:solidFill>
-                        <a:srgbClr val="888888"/>
-                      </a:solidFill>
+                    <a:lnR w="12700" cap="flat" cmpd="sng">
+                      <a:solidFill>
+                        <a:srgbClr val="000000"/>
+                      </a:solidFill>
+                      <a:prstDash val="solid"/>
                     </a:lnR>
-                    <a:lnT w="12700">
-                      <a:solidFill>
-                        <a:srgbClr val="888888"/>
-                      </a:solidFill>
+                    <a:lnT w="12700" cap="flat" cmpd="sng">
+                      <a:solidFill>
+                        <a:srgbClr val="000000"/>
+                      </a:solidFill>
+                      <a:prstDash val="solid"/>
                     </a:lnT>
-                    <a:lnB w="12700">
-                      <a:solidFill>
-                        <a:srgbClr val="888888"/>
-                      </a:solidFill>
+                    <a:lnB w="12700" cap="flat" cmpd="sng">
+                      <a:solidFill>
+                        <a:srgbClr val="000000"/>
+                      </a:solidFill>
+                      <a:prstDash val="solid"/>
                     </a:lnB>
                   </a:tcPr>
                 </a:tc>
@@ -4204,25 +4312,29 @@
                   </a:txBody>
                   <a:tcPr>
                     <a:noFill/>
-                    <a:lnL w="12700">
-                      <a:solidFill>
-                        <a:srgbClr val="888888"/>
-                      </a:solidFill>
+                    <a:lnL w="12700" cap="flat" cmpd="sng">
+                      <a:solidFill>
+                        <a:srgbClr val="000000"/>
+                      </a:solidFill>
+                      <a:prstDash val="solid"/>
                     </a:lnL>
-                    <a:lnR w="12700">
-                      <a:solidFill>
-                        <a:srgbClr val="888888"/>
-                      </a:solidFill>
+                    <a:lnR w="12700" cap="flat" cmpd="sng">
+                      <a:solidFill>
+                        <a:srgbClr val="000000"/>
+                      </a:solidFill>
+                      <a:prstDash val="solid"/>
                     </a:lnR>
-                    <a:lnT w="12700">
-                      <a:solidFill>
-                        <a:srgbClr val="888888"/>
-                      </a:solidFill>
+                    <a:lnT w="12700" cap="flat" cmpd="sng">
+                      <a:solidFill>
+                        <a:srgbClr val="000000"/>
+                      </a:solidFill>
+                      <a:prstDash val="solid"/>
                     </a:lnT>
-                    <a:lnB w="12700">
-                      <a:solidFill>
-                        <a:srgbClr val="888888"/>
-                      </a:solidFill>
+                    <a:lnB w="12700" cap="flat" cmpd="sng">
+                      <a:solidFill>
+                        <a:srgbClr val="000000"/>
+                      </a:solidFill>
+                      <a:prstDash val="solid"/>
                     </a:lnB>
                   </a:tcPr>
                 </a:tc>
@@ -4242,25 +4354,29 @@
                   </a:txBody>
                   <a:tcPr>
                     <a:noFill/>
-                    <a:lnL w="12700">
-                      <a:solidFill>
-                        <a:srgbClr val="888888"/>
-                      </a:solidFill>
+                    <a:lnL w="12700" cap="flat" cmpd="sng">
+                      <a:solidFill>
+                        <a:srgbClr val="000000"/>
+                      </a:solidFill>
+                      <a:prstDash val="solid"/>
                     </a:lnL>
-                    <a:lnR w="12700">
-                      <a:solidFill>
-                        <a:srgbClr val="888888"/>
-                      </a:solidFill>
+                    <a:lnR w="12700" cap="flat" cmpd="sng">
+                      <a:solidFill>
+                        <a:srgbClr val="000000"/>
+                      </a:solidFill>
+                      <a:prstDash val="solid"/>
                     </a:lnR>
-                    <a:lnT w="12700">
-                      <a:solidFill>
-                        <a:srgbClr val="888888"/>
-                      </a:solidFill>
+                    <a:lnT w="12700" cap="flat" cmpd="sng">
+                      <a:solidFill>
+                        <a:srgbClr val="000000"/>
+                      </a:solidFill>
+                      <a:prstDash val="solid"/>
                     </a:lnT>
-                    <a:lnB w="12700">
-                      <a:solidFill>
-                        <a:srgbClr val="888888"/>
-                      </a:solidFill>
+                    <a:lnB w="12700" cap="flat" cmpd="sng">
+                      <a:solidFill>
+                        <a:srgbClr val="000000"/>
+                      </a:solidFill>
+                      <a:prstDash val="solid"/>
                     </a:lnB>
                   </a:tcPr>
                 </a:tc>
@@ -4280,25 +4396,29 @@
                   </a:txBody>
                   <a:tcPr>
                     <a:noFill/>
-                    <a:lnL w="12700">
-                      <a:solidFill>
-                        <a:srgbClr val="888888"/>
-                      </a:solidFill>
+                    <a:lnL w="12700" cap="flat" cmpd="sng">
+                      <a:solidFill>
+                        <a:srgbClr val="000000"/>
+                      </a:solidFill>
+                      <a:prstDash val="solid"/>
                     </a:lnL>
-                    <a:lnR w="12700">
-                      <a:solidFill>
-                        <a:srgbClr val="888888"/>
-                      </a:solidFill>
+                    <a:lnR w="12700" cap="flat" cmpd="sng">
+                      <a:solidFill>
+                        <a:srgbClr val="000000"/>
+                      </a:solidFill>
+                      <a:prstDash val="solid"/>
                     </a:lnR>
-                    <a:lnT w="12700">
-                      <a:solidFill>
-                        <a:srgbClr val="888888"/>
-                      </a:solidFill>
+                    <a:lnT w="12700" cap="flat" cmpd="sng">
+                      <a:solidFill>
+                        <a:srgbClr val="000000"/>
+                      </a:solidFill>
+                      <a:prstDash val="solid"/>
                     </a:lnT>
-                    <a:lnB w="12700">
-                      <a:solidFill>
-                        <a:srgbClr val="888888"/>
-                      </a:solidFill>
+                    <a:lnB w="12700" cap="flat" cmpd="sng">
+                      <a:solidFill>
+                        <a:srgbClr val="000000"/>
+                      </a:solidFill>
+                      <a:prstDash val="solid"/>
                     </a:lnB>
                   </a:tcPr>
                 </a:tc>
@@ -4320,25 +4440,29 @@
                   </a:txBody>
                   <a:tcPr>
                     <a:noFill/>
-                    <a:lnL w="12700">
-                      <a:solidFill>
-                        <a:srgbClr val="888888"/>
-                      </a:solidFill>
+                    <a:lnL w="12700" cap="flat" cmpd="sng">
+                      <a:solidFill>
+                        <a:srgbClr val="000000"/>
+                      </a:solidFill>
+                      <a:prstDash val="solid"/>
                     </a:lnL>
-                    <a:lnR w="12700">
-                      <a:solidFill>
-                        <a:srgbClr val="888888"/>
-                      </a:solidFill>
+                    <a:lnR w="12700" cap="flat" cmpd="sng">
+                      <a:solidFill>
+                        <a:srgbClr val="000000"/>
+                      </a:solidFill>
+                      <a:prstDash val="solid"/>
                     </a:lnR>
-                    <a:lnT w="12700">
-                      <a:solidFill>
-                        <a:srgbClr val="888888"/>
-                      </a:solidFill>
+                    <a:lnT w="12700" cap="flat" cmpd="sng">
+                      <a:solidFill>
+                        <a:srgbClr val="000000"/>
+                      </a:solidFill>
+                      <a:prstDash val="solid"/>
                     </a:lnT>
-                    <a:lnB w="12700">
-                      <a:solidFill>
-                        <a:srgbClr val="888888"/>
-                      </a:solidFill>
+                    <a:lnB w="12700" cap="flat" cmpd="sng">
+                      <a:solidFill>
+                        <a:srgbClr val="000000"/>
+                      </a:solidFill>
+                      <a:prstDash val="solid"/>
                     </a:lnB>
                   </a:tcPr>
                 </a:tc>
@@ -4358,25 +4482,29 @@
                   </a:txBody>
                   <a:tcPr>
                     <a:noFill/>
-                    <a:lnL w="12700">
-                      <a:solidFill>
-                        <a:srgbClr val="888888"/>
-                      </a:solidFill>
+                    <a:lnL w="12700" cap="flat" cmpd="sng">
+                      <a:solidFill>
+                        <a:srgbClr val="000000"/>
+                      </a:solidFill>
+                      <a:prstDash val="solid"/>
                     </a:lnL>
-                    <a:lnR w="12700">
-                      <a:solidFill>
-                        <a:srgbClr val="888888"/>
-                      </a:solidFill>
+                    <a:lnR w="12700" cap="flat" cmpd="sng">
+                      <a:solidFill>
+                        <a:srgbClr val="000000"/>
+                      </a:solidFill>
+                      <a:prstDash val="solid"/>
                     </a:lnR>
-                    <a:lnT w="12700">
-                      <a:solidFill>
-                        <a:srgbClr val="888888"/>
-                      </a:solidFill>
+                    <a:lnT w="12700" cap="flat" cmpd="sng">
+                      <a:solidFill>
+                        <a:srgbClr val="000000"/>
+                      </a:solidFill>
+                      <a:prstDash val="solid"/>
                     </a:lnT>
-                    <a:lnB w="12700">
-                      <a:solidFill>
-                        <a:srgbClr val="888888"/>
-                      </a:solidFill>
+                    <a:lnB w="12700" cap="flat" cmpd="sng">
+                      <a:solidFill>
+                        <a:srgbClr val="000000"/>
+                      </a:solidFill>
+                      <a:prstDash val="solid"/>
                     </a:lnB>
                   </a:tcPr>
                 </a:tc>
@@ -4396,25 +4524,29 @@
                   </a:txBody>
                   <a:tcPr>
                     <a:noFill/>
-                    <a:lnL w="12700">
-                      <a:solidFill>
-                        <a:srgbClr val="888888"/>
-                      </a:solidFill>
+                    <a:lnL w="12700" cap="flat" cmpd="sng">
+                      <a:solidFill>
+                        <a:srgbClr val="000000"/>
+                      </a:solidFill>
+                      <a:prstDash val="solid"/>
                     </a:lnL>
-                    <a:lnR w="12700">
-                      <a:solidFill>
-                        <a:srgbClr val="888888"/>
-                      </a:solidFill>
+                    <a:lnR w="12700" cap="flat" cmpd="sng">
+                      <a:solidFill>
+                        <a:srgbClr val="000000"/>
+                      </a:solidFill>
+                      <a:prstDash val="solid"/>
                     </a:lnR>
-                    <a:lnT w="12700">
-                      <a:solidFill>
-                        <a:srgbClr val="888888"/>
-                      </a:solidFill>
+                    <a:lnT w="12700" cap="flat" cmpd="sng">
+                      <a:solidFill>
+                        <a:srgbClr val="000000"/>
+                      </a:solidFill>
+                      <a:prstDash val="solid"/>
                     </a:lnT>
-                    <a:lnB w="12700">
-                      <a:solidFill>
-                        <a:srgbClr val="888888"/>
-                      </a:solidFill>
+                    <a:lnB w="12700" cap="flat" cmpd="sng">
+                      <a:solidFill>
+                        <a:srgbClr val="000000"/>
+                      </a:solidFill>
+                      <a:prstDash val="solid"/>
                     </a:lnB>
                   </a:tcPr>
                 </a:tc>
@@ -4434,25 +4566,29 @@
                   </a:txBody>
                   <a:tcPr>
                     <a:noFill/>
-                    <a:lnL w="12700">
-                      <a:solidFill>
-                        <a:srgbClr val="888888"/>
-                      </a:solidFill>
+                    <a:lnL w="12700" cap="flat" cmpd="sng">
+                      <a:solidFill>
+                        <a:srgbClr val="000000"/>
+                      </a:solidFill>
+                      <a:prstDash val="solid"/>
                     </a:lnL>
-                    <a:lnR w="12700">
-                      <a:solidFill>
-                        <a:srgbClr val="888888"/>
-                      </a:solidFill>
+                    <a:lnR w="12700" cap="flat" cmpd="sng">
+                      <a:solidFill>
+                        <a:srgbClr val="000000"/>
+                      </a:solidFill>
+                      <a:prstDash val="solid"/>
                     </a:lnR>
-                    <a:lnT w="12700">
-                      <a:solidFill>
-                        <a:srgbClr val="888888"/>
-                      </a:solidFill>
+                    <a:lnT w="12700" cap="flat" cmpd="sng">
+                      <a:solidFill>
+                        <a:srgbClr val="000000"/>
+                      </a:solidFill>
+                      <a:prstDash val="solid"/>
                     </a:lnT>
-                    <a:lnB w="12700">
-                      <a:solidFill>
-                        <a:srgbClr val="888888"/>
-                      </a:solidFill>
+                    <a:lnB w="12700" cap="flat" cmpd="sng">
+                      <a:solidFill>
+                        <a:srgbClr val="000000"/>
+                      </a:solidFill>
+                      <a:prstDash val="solid"/>
                     </a:lnB>
                   </a:tcPr>
                 </a:tc>
@@ -4472,25 +4608,29 @@
                   </a:txBody>
                   <a:tcPr>
                     <a:noFill/>
-                    <a:lnL w="12700">
-                      <a:solidFill>
-                        <a:srgbClr val="888888"/>
-                      </a:solidFill>
+                    <a:lnL w="12700" cap="flat" cmpd="sng">
+                      <a:solidFill>
+                        <a:srgbClr val="000000"/>
+                      </a:solidFill>
+                      <a:prstDash val="solid"/>
                     </a:lnL>
-                    <a:lnR w="12700">
-                      <a:solidFill>
-                        <a:srgbClr val="888888"/>
-                      </a:solidFill>
+                    <a:lnR w="12700" cap="flat" cmpd="sng">
+                      <a:solidFill>
+                        <a:srgbClr val="000000"/>
+                      </a:solidFill>
+                      <a:prstDash val="solid"/>
                     </a:lnR>
-                    <a:lnT w="12700">
-                      <a:solidFill>
-                        <a:srgbClr val="888888"/>
-                      </a:solidFill>
+                    <a:lnT w="12700" cap="flat" cmpd="sng">
+                      <a:solidFill>
+                        <a:srgbClr val="000000"/>
+                      </a:solidFill>
+                      <a:prstDash val="solid"/>
                     </a:lnT>
-                    <a:lnB w="12700">
-                      <a:solidFill>
-                        <a:srgbClr val="888888"/>
-                      </a:solidFill>
+                    <a:lnB w="12700" cap="flat" cmpd="sng">
+                      <a:solidFill>
+                        <a:srgbClr val="000000"/>
+                      </a:solidFill>
+                      <a:prstDash val="solid"/>
                     </a:lnB>
                   </a:tcPr>
                 </a:tc>

</xml_diff>